<commit_message>
Shapes drawn on charts (c:userShapes)
The chart drawing's anchors place their shapes in the chart frame (relSizeAnchor
by fractions, absSizeAnchor by size); the shapes are drawn like slide shapes,
their text defaulting to the chart's (10 pt, measured).

Co-Authored-By: Claude Opus 5.5 <noreply@anthropic.com>
</commit_message>
<xml_diff>
--- a/tests/corpus/pptx/generated/charts-more.pptx
+++ b/tests/corpus/pptx/generated/charts-more.pptx
@@ -12,6 +12,7 @@
     <p:sldId id="260" r:id="rId6"/>
     <p:sldId id="261" r:id="rId7"/>
     <p:sldId id="262" r:id="rId8"/>
+    <p:sldId id="263" r:id="rId9"/>
   </p:sldIdLst>
   <p:sldSz cx="12192000" cy="6858000"/>
   <p:notesSz cx="6858000" cy="9144000"/>
@@ -209,7 +210,7 @@
           </c:val>
           <c:extLst>
             <c:ext xmlns:c16="http://schemas.microsoft.com/office/drawing/2014/chart" uri="{C3380CC4-5D6E-409C-BE32-E72D297353CC}">
-              <c16:uniqueId val="{00000000-355E-45E6-983C-6F954790717A}"/>
+              <c16:uniqueId val="{00000000-2BC3-40C6-990B-68EEF8C5F658}"/>
             </c:ext>
           </c:extLst>
         </c:ser>
@@ -289,7 +290,7 @@
           </c:val>
           <c:extLst>
             <c:ext xmlns:c16="http://schemas.microsoft.com/office/drawing/2014/chart" uri="{C3380CC4-5D6E-409C-BE32-E72D297353CC}">
-              <c16:uniqueId val="{00000001-355E-45E6-983C-6F954790717A}"/>
+              <c16:uniqueId val="{00000001-2BC3-40C6-990B-68EEF8C5F658}"/>
             </c:ext>
           </c:extLst>
         </c:ser>
@@ -301,11 +302,11 @@
           <c:showPercent val="0"/>
           <c:showBubbleSize val="0"/>
         </c:dLbls>
-        <c:axId val="1443822352"/>
-        <c:axId val="1019419280"/>
+        <c:axId val="1211406768"/>
+        <c:axId val="1019310320"/>
       </c:radarChart>
       <c:catAx>
-        <c:axId val="1443822352"/>
+        <c:axId val="1211406768"/>
         <c:scaling>
           <c:orientation val="minMax"/>
         </c:scaling>
@@ -348,7 +349,7 @@
             <a:endParaRPr lang="de-DE"/>
           </a:p>
         </c:txPr>
-        <c:crossAx val="1019419280"/>
+        <c:crossAx val="1019310320"/>
         <c:crosses val="autoZero"/>
         <c:auto val="1"/>
         <c:lblAlgn val="ctr"/>
@@ -356,7 +357,7 @@
         <c:noMultiLvlLbl val="0"/>
       </c:catAx>
       <c:valAx>
-        <c:axId val="1019419280"/>
+        <c:axId val="1019310320"/>
         <c:scaling>
           <c:orientation val="minMax"/>
         </c:scaling>
@@ -407,7 +408,7 @@
             <a:endParaRPr lang="de-DE"/>
           </a:p>
         </c:txPr>
-        <c:crossAx val="1443822352"/>
+        <c:crossAx val="1211406768"/>
         <c:crosses val="autoZero"/>
         <c:crossBetween val="between"/>
       </c:valAx>
@@ -484,7 +485,7 @@
 </c:chartSpace>
 </file>
 
-<file path=ppt/charts/chart2.xml><?xml version="1.0" encoding="utf-8"?>
+<file path=ppt/charts/chart10.xml><?xml version="1.0" encoding="utf-8"?>
 <c:chartSpace xmlns:c="http://schemas.openxmlformats.org/drawingml/2006/chart" xmlns:a="http://schemas.openxmlformats.org/drawingml/2006/main" xmlns:r="http://schemas.openxmlformats.org/officeDocument/2006/relationships" xmlns:c16r2="http://schemas.microsoft.com/office/drawing/2015/06/chart">
   <c:date1904 val="0"/>
   <c:lang val="de-DE"/>
@@ -501,8 +502,9 @@
     <c:autoTitleDeleted val="0"/>
     <c:plotArea>
       <c:layout/>
-      <c:radarChart>
-        <c:radarStyle val="filled"/>
+      <c:barChart>
+        <c:barDir val="col"/>
+        <c:grouping val="clustered"/>
         <c:varyColors val="0"/>
         <c:ser>
           <c:idx val="0"/>
@@ -527,57 +529,51 @@
             </a:ln>
             <a:effectLst/>
           </c:spPr>
+          <c:invertIfNegative val="0"/>
           <c:cat>
-            <c:numRef>
-              <c:f>Tabelle1!$A$2:$A$6</c:f>
-              <c:numCache>
-                <c:formatCode>m/d/yyyy</c:formatCode>
-                <c:ptCount val="5"/>
+            <c:strRef>
+              <c:f>Tabelle1!$A$2:$A$5</c:f>
+              <c:strCache>
+                <c:ptCount val="4"/>
                 <c:pt idx="0">
-                  <c:v>37377</c:v>
+                  <c:v>Kategorie 1</c:v>
                 </c:pt>
                 <c:pt idx="1">
-                  <c:v>37408</c:v>
+                  <c:v>Kategorie 2</c:v>
                 </c:pt>
                 <c:pt idx="2">
-                  <c:v>37438</c:v>
+                  <c:v>Kategorie 3</c:v>
                 </c:pt>
                 <c:pt idx="3">
-                  <c:v>37469</c:v>
-                </c:pt>
-                <c:pt idx="4">
-                  <c:v>37500</c:v>
-                </c:pt>
-              </c:numCache>
-            </c:numRef>
+                  <c:v>Kategorie 4</c:v>
+                </c:pt>
+              </c:strCache>
+            </c:strRef>
           </c:cat>
           <c:val>
             <c:numRef>
-              <c:f>Tabelle1!$B$2:$B$6</c:f>
+              <c:f>Tabelle1!$B$2:$B$5</c:f>
               <c:numCache>
                 <c:formatCode>General</c:formatCode>
-                <c:ptCount val="5"/>
+                <c:ptCount val="4"/>
                 <c:pt idx="0">
-                  <c:v>32</c:v>
+                  <c:v>4.3</c:v>
                 </c:pt>
                 <c:pt idx="1">
-                  <c:v>32</c:v>
+                  <c:v>2.5</c:v>
                 </c:pt>
                 <c:pt idx="2">
-                  <c:v>28</c:v>
+                  <c:v>3.5</c:v>
                 </c:pt>
                 <c:pt idx="3">
-                  <c:v>12</c:v>
-                </c:pt>
-                <c:pt idx="4">
-                  <c:v>15</c:v>
+                  <c:v>4.5</c:v>
                 </c:pt>
               </c:numCache>
             </c:numRef>
           </c:val>
           <c:extLst>
             <c:ext xmlns:c16="http://schemas.microsoft.com/office/drawing/2014/chart" uri="{C3380CC4-5D6E-409C-BE32-E72D297353CC}">
-              <c16:uniqueId val="{00000000-2D8C-440E-B91F-AC8D244FE7BA}"/>
+              <c16:uniqueId val="{00000000-38CF-4F75-BA7D-7CC0F5F60D12}"/>
             </c:ext>
           </c:extLst>
         </c:ser>
@@ -604,57 +600,122 @@
             </a:ln>
             <a:effectLst/>
           </c:spPr>
+          <c:invertIfNegative val="0"/>
           <c:cat>
-            <c:numRef>
-              <c:f>Tabelle1!$A$2:$A$6</c:f>
-              <c:numCache>
-                <c:formatCode>m/d/yyyy</c:formatCode>
-                <c:ptCount val="5"/>
+            <c:strRef>
+              <c:f>Tabelle1!$A$2:$A$5</c:f>
+              <c:strCache>
+                <c:ptCount val="4"/>
                 <c:pt idx="0">
-                  <c:v>37377</c:v>
+                  <c:v>Kategorie 1</c:v>
                 </c:pt>
                 <c:pt idx="1">
-                  <c:v>37408</c:v>
+                  <c:v>Kategorie 2</c:v>
                 </c:pt>
                 <c:pt idx="2">
-                  <c:v>37438</c:v>
+                  <c:v>Kategorie 3</c:v>
                 </c:pt>
                 <c:pt idx="3">
-                  <c:v>37469</c:v>
-                </c:pt>
-                <c:pt idx="4">
-                  <c:v>37500</c:v>
-                </c:pt>
-              </c:numCache>
-            </c:numRef>
+                  <c:v>Kategorie 4</c:v>
+                </c:pt>
+              </c:strCache>
+            </c:strRef>
           </c:cat>
           <c:val>
             <c:numRef>
-              <c:f>Tabelle1!$C$2:$C$6</c:f>
+              <c:f>Tabelle1!$C$2:$C$5</c:f>
               <c:numCache>
                 <c:formatCode>General</c:formatCode>
-                <c:ptCount val="5"/>
+                <c:ptCount val="4"/>
                 <c:pt idx="0">
-                  <c:v>12</c:v>
+                  <c:v>2.4</c:v>
                 </c:pt>
                 <c:pt idx="1">
-                  <c:v>12</c:v>
+                  <c:v>4.4000000000000004</c:v>
                 </c:pt>
                 <c:pt idx="2">
-                  <c:v>12</c:v>
+                  <c:v>1.8</c:v>
                 </c:pt>
                 <c:pt idx="3">
-                  <c:v>21</c:v>
-                </c:pt>
-                <c:pt idx="4">
-                  <c:v>28</c:v>
+                  <c:v>2.8</c:v>
                 </c:pt>
               </c:numCache>
             </c:numRef>
           </c:val>
           <c:extLst>
             <c:ext xmlns:c16="http://schemas.microsoft.com/office/drawing/2014/chart" uri="{C3380CC4-5D6E-409C-BE32-E72D297353CC}">
-              <c16:uniqueId val="{00000001-2D8C-440E-B91F-AC8D244FE7BA}"/>
+              <c16:uniqueId val="{00000001-38CF-4F75-BA7D-7CC0F5F60D12}"/>
+            </c:ext>
+          </c:extLst>
+        </c:ser>
+        <c:ser>
+          <c:idx val="2"/>
+          <c:order val="2"/>
+          <c:tx>
+            <c:strRef>
+              <c:f>Tabelle1!$D$1</c:f>
+              <c:strCache>
+                <c:ptCount val="1"/>
+                <c:pt idx="0">
+                  <c:v>Datenreihe 3</c:v>
+                </c:pt>
+              </c:strCache>
+            </c:strRef>
+          </c:tx>
+          <c:spPr>
+            <a:solidFill>
+              <a:schemeClr val="accent3"/>
+            </a:solidFill>
+            <a:ln>
+              <a:noFill/>
+            </a:ln>
+            <a:effectLst/>
+          </c:spPr>
+          <c:invertIfNegative val="0"/>
+          <c:cat>
+            <c:strRef>
+              <c:f>Tabelle1!$A$2:$A$5</c:f>
+              <c:strCache>
+                <c:ptCount val="4"/>
+                <c:pt idx="0">
+                  <c:v>Kategorie 1</c:v>
+                </c:pt>
+                <c:pt idx="1">
+                  <c:v>Kategorie 2</c:v>
+                </c:pt>
+                <c:pt idx="2">
+                  <c:v>Kategorie 3</c:v>
+                </c:pt>
+                <c:pt idx="3">
+                  <c:v>Kategorie 4</c:v>
+                </c:pt>
+              </c:strCache>
+            </c:strRef>
+          </c:cat>
+          <c:val>
+            <c:numRef>
+              <c:f>Tabelle1!$D$2:$D$5</c:f>
+              <c:numCache>
+                <c:formatCode>General</c:formatCode>
+                <c:ptCount val="4"/>
+                <c:pt idx="0">
+                  <c:v>2</c:v>
+                </c:pt>
+                <c:pt idx="1">
+                  <c:v>2</c:v>
+                </c:pt>
+                <c:pt idx="2">
+                  <c:v>3</c:v>
+                </c:pt>
+                <c:pt idx="3">
+                  <c:v>5</c:v>
+                </c:pt>
+              </c:numCache>
+            </c:numRef>
+          </c:val>
+          <c:extLst>
+            <c:ext xmlns:c16="http://schemas.microsoft.com/office/drawing/2014/chart" uri="{C3380CC4-5D6E-409C-BE32-E72D297353CC}">
+              <c16:uniqueId val="{00000002-38CF-4F75-BA7D-7CC0F5F60D12}"/>
             </c:ext>
           </c:extLst>
         </c:ser>
@@ -666,17 +727,19 @@
           <c:showPercent val="0"/>
           <c:showBubbleSize val="0"/>
         </c:dLbls>
-        <c:axId val="1448254800"/>
-        <c:axId val="1019230160"/>
-      </c:radarChart>
+        <c:gapWidth val="219"/>
+        <c:overlap val="-27"/>
+        <c:axId val="1443826528"/>
+        <c:axId val="1019324240"/>
+      </c:barChart>
       <c:catAx>
-        <c:axId val="1448254800"/>
+        <c:axId val="1443826528"/>
         <c:scaling>
           <c:orientation val="minMax"/>
         </c:scaling>
         <c:delete val="0"/>
         <c:axPos val="b"/>
-        <c:numFmt formatCode="m/d/yyyy" sourceLinked="1"/>
+        <c:numFmt formatCode="General" sourceLinked="1"/>
         <c:majorTickMark val="none"/>
         <c:minorTickMark val="none"/>
         <c:tickLblPos val="nextTo"/>
@@ -713,7 +776,7 @@
             <a:endParaRPr lang="de-DE"/>
           </a:p>
         </c:txPr>
-        <c:crossAx val="1019230160"/>
+        <c:crossAx val="1019324240"/>
         <c:crosses val="autoZero"/>
         <c:auto val="1"/>
         <c:lblAlgn val="ctr"/>
@@ -721,7 +784,7 @@
         <c:noMultiLvlLbl val="0"/>
       </c:catAx>
       <c:valAx>
-        <c:axId val="1019230160"/>
+        <c:axId val="1019324240"/>
         <c:scaling>
           <c:orientation val="minMax"/>
         </c:scaling>
@@ -772,7 +835,373 @@
             <a:endParaRPr lang="de-DE"/>
           </a:p>
         </c:txPr>
-        <c:crossAx val="1448254800"/>
+        <c:crossAx val="1443826528"/>
+        <c:crosses val="autoZero"/>
+        <c:crossBetween val="between"/>
+      </c:valAx>
+      <c:spPr>
+        <a:noFill/>
+        <a:ln>
+          <a:noFill/>
+        </a:ln>
+        <a:effectLst/>
+      </c:spPr>
+    </c:plotArea>
+    <c:legend>
+      <c:legendPos val="b"/>
+      <c:overlay val="0"/>
+      <c:spPr>
+        <a:noFill/>
+        <a:ln>
+          <a:noFill/>
+        </a:ln>
+        <a:effectLst/>
+      </c:spPr>
+      <c:txPr>
+        <a:bodyPr rot="0" spcFirstLastPara="1" vertOverflow="ellipsis" vert="horz" wrap="square" anchor="ctr" anchorCtr="1"/>
+        <a:lstStyle/>
+        <a:p>
+          <a:pPr>
+            <a:defRPr sz="1197" b="0" i="0" u="none" strike="noStrike" kern="1200" baseline="0">
+              <a:solidFill>
+                <a:schemeClr val="tx1">
+                  <a:lumMod val="65000"/>
+                  <a:lumOff val="35000"/>
+                </a:schemeClr>
+              </a:solidFill>
+              <a:latin typeface="+mn-lt"/>
+              <a:ea typeface="+mn-ea"/>
+              <a:cs typeface="+mn-cs"/>
+            </a:defRPr>
+          </a:pPr>
+          <a:endParaRPr lang="de-DE"/>
+        </a:p>
+      </c:txPr>
+    </c:legend>
+    <c:plotVisOnly val="1"/>
+    <c:dispBlanksAs val="gap"/>
+    <c:showDLblsOverMax val="0"/>
+    <c:extLst>
+      <c:ext xmlns:c16r3="http://schemas.microsoft.com/office/drawing/2017/03/chart" uri="{56B9EC1D-385E-4148-901F-78D8002777C0}">
+        <c16r3:dataDisplayOptions16>
+          <c16r3:dispNaAsBlank val="1"/>
+        </c16r3:dataDisplayOptions16>
+      </c:ext>
+    </c:extLst>
+  </c:chart>
+  <c:spPr>
+    <a:noFill/>
+    <a:ln>
+      <a:noFill/>
+    </a:ln>
+    <a:effectLst/>
+  </c:spPr>
+  <c:txPr>
+    <a:bodyPr/>
+    <a:lstStyle/>
+    <a:p>
+      <a:pPr>
+        <a:defRPr/>
+      </a:pPr>
+      <a:endParaRPr lang="de-DE"/>
+    </a:p>
+  </c:txPr>
+  <c:externalData r:id="rId3">
+    <c:autoUpdate val="0"/>
+  </c:externalData>
+  <c:userShapes r:id="rId4"/>
+</c:chartSpace>
+</file>
+
+<file path=ppt/charts/chart2.xml><?xml version="1.0" encoding="utf-8"?>
+<c:chartSpace xmlns:c="http://schemas.openxmlformats.org/drawingml/2006/chart" xmlns:a="http://schemas.openxmlformats.org/drawingml/2006/main" xmlns:r="http://schemas.openxmlformats.org/officeDocument/2006/relationships" xmlns:c16r2="http://schemas.microsoft.com/office/drawing/2015/06/chart">
+  <c:date1904 val="0"/>
+  <c:lang val="de-DE"/>
+  <c:roundedCorners val="0"/>
+  <mc:AlternateContent xmlns:mc="http://schemas.openxmlformats.org/markup-compatibility/2006">
+    <mc:Choice xmlns:c14="http://schemas.microsoft.com/office/drawing/2007/8/2/chart" Requires="c14">
+      <c14:style val="102"/>
+    </mc:Choice>
+    <mc:Fallback>
+      <c:style val="2"/>
+    </mc:Fallback>
+  </mc:AlternateContent>
+  <c:chart>
+    <c:autoTitleDeleted val="0"/>
+    <c:plotArea>
+      <c:layout/>
+      <c:radarChart>
+        <c:radarStyle val="filled"/>
+        <c:varyColors val="0"/>
+        <c:ser>
+          <c:idx val="0"/>
+          <c:order val="0"/>
+          <c:tx>
+            <c:strRef>
+              <c:f>Tabelle1!$B$1</c:f>
+              <c:strCache>
+                <c:ptCount val="1"/>
+                <c:pt idx="0">
+                  <c:v>Datenreihe 1</c:v>
+                </c:pt>
+              </c:strCache>
+            </c:strRef>
+          </c:tx>
+          <c:spPr>
+            <a:solidFill>
+              <a:schemeClr val="accent1"/>
+            </a:solidFill>
+            <a:ln>
+              <a:noFill/>
+            </a:ln>
+            <a:effectLst/>
+          </c:spPr>
+          <c:cat>
+            <c:numRef>
+              <c:f>Tabelle1!$A$2:$A$6</c:f>
+              <c:numCache>
+                <c:formatCode>m/d/yyyy</c:formatCode>
+                <c:ptCount val="5"/>
+                <c:pt idx="0">
+                  <c:v>37377</c:v>
+                </c:pt>
+                <c:pt idx="1">
+                  <c:v>37408</c:v>
+                </c:pt>
+                <c:pt idx="2">
+                  <c:v>37438</c:v>
+                </c:pt>
+                <c:pt idx="3">
+                  <c:v>37469</c:v>
+                </c:pt>
+                <c:pt idx="4">
+                  <c:v>37500</c:v>
+                </c:pt>
+              </c:numCache>
+            </c:numRef>
+          </c:cat>
+          <c:val>
+            <c:numRef>
+              <c:f>Tabelle1!$B$2:$B$6</c:f>
+              <c:numCache>
+                <c:formatCode>General</c:formatCode>
+                <c:ptCount val="5"/>
+                <c:pt idx="0">
+                  <c:v>32</c:v>
+                </c:pt>
+                <c:pt idx="1">
+                  <c:v>32</c:v>
+                </c:pt>
+                <c:pt idx="2">
+                  <c:v>28</c:v>
+                </c:pt>
+                <c:pt idx="3">
+                  <c:v>12</c:v>
+                </c:pt>
+                <c:pt idx="4">
+                  <c:v>15</c:v>
+                </c:pt>
+              </c:numCache>
+            </c:numRef>
+          </c:val>
+          <c:extLst>
+            <c:ext xmlns:c16="http://schemas.microsoft.com/office/drawing/2014/chart" uri="{C3380CC4-5D6E-409C-BE32-E72D297353CC}">
+              <c16:uniqueId val="{00000000-64C9-4D57-9491-90B90A6F12B6}"/>
+            </c:ext>
+          </c:extLst>
+        </c:ser>
+        <c:ser>
+          <c:idx val="1"/>
+          <c:order val="1"/>
+          <c:tx>
+            <c:strRef>
+              <c:f>Tabelle1!$C$1</c:f>
+              <c:strCache>
+                <c:ptCount val="1"/>
+                <c:pt idx="0">
+                  <c:v>Datenreihe 2</c:v>
+                </c:pt>
+              </c:strCache>
+            </c:strRef>
+          </c:tx>
+          <c:spPr>
+            <a:solidFill>
+              <a:schemeClr val="accent2"/>
+            </a:solidFill>
+            <a:ln>
+              <a:noFill/>
+            </a:ln>
+            <a:effectLst/>
+          </c:spPr>
+          <c:cat>
+            <c:numRef>
+              <c:f>Tabelle1!$A$2:$A$6</c:f>
+              <c:numCache>
+                <c:formatCode>m/d/yyyy</c:formatCode>
+                <c:ptCount val="5"/>
+                <c:pt idx="0">
+                  <c:v>37377</c:v>
+                </c:pt>
+                <c:pt idx="1">
+                  <c:v>37408</c:v>
+                </c:pt>
+                <c:pt idx="2">
+                  <c:v>37438</c:v>
+                </c:pt>
+                <c:pt idx="3">
+                  <c:v>37469</c:v>
+                </c:pt>
+                <c:pt idx="4">
+                  <c:v>37500</c:v>
+                </c:pt>
+              </c:numCache>
+            </c:numRef>
+          </c:cat>
+          <c:val>
+            <c:numRef>
+              <c:f>Tabelle1!$C$2:$C$6</c:f>
+              <c:numCache>
+                <c:formatCode>General</c:formatCode>
+                <c:ptCount val="5"/>
+                <c:pt idx="0">
+                  <c:v>12</c:v>
+                </c:pt>
+                <c:pt idx="1">
+                  <c:v>12</c:v>
+                </c:pt>
+                <c:pt idx="2">
+                  <c:v>12</c:v>
+                </c:pt>
+                <c:pt idx="3">
+                  <c:v>21</c:v>
+                </c:pt>
+                <c:pt idx="4">
+                  <c:v>28</c:v>
+                </c:pt>
+              </c:numCache>
+            </c:numRef>
+          </c:val>
+          <c:extLst>
+            <c:ext xmlns:c16="http://schemas.microsoft.com/office/drawing/2014/chart" uri="{C3380CC4-5D6E-409C-BE32-E72D297353CC}">
+              <c16:uniqueId val="{00000001-64C9-4D57-9491-90B90A6F12B6}"/>
+            </c:ext>
+          </c:extLst>
+        </c:ser>
+        <c:dLbls>
+          <c:showLegendKey val="0"/>
+          <c:showVal val="0"/>
+          <c:showCatName val="0"/>
+          <c:showSerName val="0"/>
+          <c:showPercent val="0"/>
+          <c:showBubbleSize val="0"/>
+        </c:dLbls>
+        <c:axId val="1211391920"/>
+        <c:axId val="1019261360"/>
+      </c:radarChart>
+      <c:catAx>
+        <c:axId val="1211391920"/>
+        <c:scaling>
+          <c:orientation val="minMax"/>
+        </c:scaling>
+        <c:delete val="0"/>
+        <c:axPos val="b"/>
+        <c:numFmt formatCode="m/d/yyyy" sourceLinked="1"/>
+        <c:majorTickMark val="none"/>
+        <c:minorTickMark val="none"/>
+        <c:tickLblPos val="nextTo"/>
+        <c:spPr>
+          <a:noFill/>
+          <a:ln w="9525" cap="flat" cmpd="sng" algn="ctr">
+            <a:solidFill>
+              <a:schemeClr val="tx1">
+                <a:lumMod val="15000"/>
+                <a:lumOff val="85000"/>
+              </a:schemeClr>
+            </a:solidFill>
+            <a:round/>
+          </a:ln>
+          <a:effectLst/>
+        </c:spPr>
+        <c:txPr>
+          <a:bodyPr rot="-60000000" spcFirstLastPara="1" vertOverflow="ellipsis" vert="horz" wrap="square" anchor="ctr" anchorCtr="1"/>
+          <a:lstStyle/>
+          <a:p>
+            <a:pPr>
+              <a:defRPr sz="1197" b="0" i="0" u="none" strike="noStrike" kern="1200" baseline="0">
+                <a:solidFill>
+                  <a:schemeClr val="tx1">
+                    <a:lumMod val="65000"/>
+                    <a:lumOff val="35000"/>
+                  </a:schemeClr>
+                </a:solidFill>
+                <a:latin typeface="+mn-lt"/>
+                <a:ea typeface="+mn-ea"/>
+                <a:cs typeface="+mn-cs"/>
+              </a:defRPr>
+            </a:pPr>
+            <a:endParaRPr lang="de-DE"/>
+          </a:p>
+        </c:txPr>
+        <c:crossAx val="1019261360"/>
+        <c:crosses val="autoZero"/>
+        <c:auto val="1"/>
+        <c:lblAlgn val="ctr"/>
+        <c:lblOffset val="100"/>
+        <c:noMultiLvlLbl val="0"/>
+      </c:catAx>
+      <c:valAx>
+        <c:axId val="1019261360"/>
+        <c:scaling>
+          <c:orientation val="minMax"/>
+        </c:scaling>
+        <c:delete val="0"/>
+        <c:axPos val="l"/>
+        <c:majorGridlines>
+          <c:spPr>
+            <a:ln w="9525" cap="flat" cmpd="sng" algn="ctr">
+              <a:solidFill>
+                <a:schemeClr val="tx1">
+                  <a:lumMod val="15000"/>
+                  <a:lumOff val="85000"/>
+                </a:schemeClr>
+              </a:solidFill>
+              <a:round/>
+            </a:ln>
+            <a:effectLst/>
+          </c:spPr>
+        </c:majorGridlines>
+        <c:numFmt formatCode="General" sourceLinked="1"/>
+        <c:majorTickMark val="none"/>
+        <c:minorTickMark val="none"/>
+        <c:tickLblPos val="nextTo"/>
+        <c:spPr>
+          <a:noFill/>
+          <a:ln>
+            <a:noFill/>
+          </a:ln>
+          <a:effectLst/>
+        </c:spPr>
+        <c:txPr>
+          <a:bodyPr rot="-60000000" spcFirstLastPara="1" vertOverflow="ellipsis" vert="horz" wrap="square" anchor="ctr" anchorCtr="1"/>
+          <a:lstStyle/>
+          <a:p>
+            <a:pPr>
+              <a:defRPr sz="1197" b="0" i="0" u="none" strike="noStrike" kern="1200" baseline="0">
+                <a:solidFill>
+                  <a:schemeClr val="tx1">
+                    <a:lumMod val="65000"/>
+                    <a:lumOff val="35000"/>
+                  </a:schemeClr>
+                </a:solidFill>
+                <a:latin typeface="+mn-lt"/>
+                <a:ea typeface="+mn-ea"/>
+                <a:cs typeface="+mn-cs"/>
+              </a:defRPr>
+            </a:pPr>
+            <a:endParaRPr lang="de-DE"/>
+          </a:p>
+        </c:txPr>
+        <c:crossAx val="1211391920"/>
         <c:crosses val="autoZero"/>
         <c:crossBetween val="between"/>
       </c:valAx>
@@ -941,7 +1370,7 @@
           <c:smooth val="0"/>
           <c:extLst>
             <c:ext xmlns:c16="http://schemas.microsoft.com/office/drawing/2014/chart" uri="{C3380CC4-5D6E-409C-BE32-E72D297353CC}">
-              <c16:uniqueId val="{00000000-CB5D-4F88-B10D-E5593EFAE885}"/>
+              <c16:uniqueId val="{00000000-B9FB-4A3F-AE3C-CD1768F7EAED}"/>
             </c:ext>
           </c:extLst>
         </c:ser>
@@ -1019,7 +1448,7 @@
           <c:smooth val="0"/>
           <c:extLst>
             <c:ext xmlns:c16="http://schemas.microsoft.com/office/drawing/2014/chart" uri="{C3380CC4-5D6E-409C-BE32-E72D297353CC}">
-              <c16:uniqueId val="{00000001-CB5D-4F88-B10D-E5593EFAE885}"/>
+              <c16:uniqueId val="{00000001-B9FB-4A3F-AE3C-CD1768F7EAED}"/>
             </c:ext>
           </c:extLst>
         </c:ser>
@@ -1109,7 +1538,7 @@
           <c:smooth val="0"/>
           <c:extLst>
             <c:ext xmlns:c16="http://schemas.microsoft.com/office/drawing/2014/chart" uri="{C3380CC4-5D6E-409C-BE32-E72D297353CC}">
-              <c16:uniqueId val="{00000002-CB5D-4F88-B10D-E5593EFAE885}"/>
+              <c16:uniqueId val="{00000002-B9FB-4A3F-AE3C-CD1768F7EAED}"/>
             </c:ext>
           </c:extLst>
         </c:ser>
@@ -1135,11 +1564,11 @@
             <a:effectLst/>
           </c:spPr>
         </c:hiLowLines>
-        <c:axId val="1448270576"/>
-        <c:axId val="1019232560"/>
+        <c:axId val="1211390992"/>
+        <c:axId val="1019294960"/>
       </c:stockChart>
       <c:catAx>
-        <c:axId val="1448270576"/>
+        <c:axId val="1211390992"/>
         <c:scaling>
           <c:orientation val="minMax"/>
         </c:scaling>
@@ -1182,7 +1611,7 @@
             <a:endParaRPr lang="de-DE"/>
           </a:p>
         </c:txPr>
-        <c:crossAx val="1019232560"/>
+        <c:crossAx val="1019294960"/>
         <c:crosses val="autoZero"/>
         <c:auto val="1"/>
         <c:lblAlgn val="ctr"/>
@@ -1190,7 +1619,7 @@
         <c:noMultiLvlLbl val="0"/>
       </c:catAx>
       <c:valAx>
-        <c:axId val="1019232560"/>
+        <c:axId val="1019294960"/>
         <c:scaling>
           <c:orientation val="minMax"/>
         </c:scaling>
@@ -1241,7 +1670,7 @@
             <a:endParaRPr lang="de-DE"/>
           </a:p>
         </c:txPr>
-        <c:crossAx val="1448270576"/>
+        <c:crossAx val="1211390992"/>
         <c:crosses val="autoZero"/>
         <c:crossBetween val="between"/>
       </c:valAx>
@@ -1410,7 +1839,7 @@
           <c:smooth val="0"/>
           <c:extLst>
             <c:ext xmlns:c16="http://schemas.microsoft.com/office/drawing/2014/chart" uri="{C3380CC4-5D6E-409C-BE32-E72D297353CC}">
-              <c16:uniqueId val="{00000000-71F5-44E4-B04C-150C520960BF}"/>
+              <c16:uniqueId val="{00000000-6A69-49CC-A284-C75A47A4598D}"/>
             </c:ext>
           </c:extLst>
         </c:ser>
@@ -1488,7 +1917,7 @@
           <c:smooth val="0"/>
           <c:extLst>
             <c:ext xmlns:c16="http://schemas.microsoft.com/office/drawing/2014/chart" uri="{C3380CC4-5D6E-409C-BE32-E72D297353CC}">
-              <c16:uniqueId val="{00000001-71F5-44E4-B04C-150C520960BF}"/>
+              <c16:uniqueId val="{00000001-6A69-49CC-A284-C75A47A4598D}"/>
             </c:ext>
           </c:extLst>
         </c:ser>
@@ -1566,7 +1995,7 @@
           <c:smooth val="0"/>
           <c:extLst>
             <c:ext xmlns:c16="http://schemas.microsoft.com/office/drawing/2014/chart" uri="{C3380CC4-5D6E-409C-BE32-E72D297353CC}">
-              <c16:uniqueId val="{00000002-71F5-44E4-B04C-150C520960BF}"/>
+              <c16:uniqueId val="{00000002-6A69-49CC-A284-C75A47A4598D}"/>
             </c:ext>
           </c:extLst>
         </c:ser>
@@ -1644,7 +2073,7 @@
           <c:smooth val="0"/>
           <c:extLst>
             <c:ext xmlns:c16="http://schemas.microsoft.com/office/drawing/2014/chart" uri="{C3380CC4-5D6E-409C-BE32-E72D297353CC}">
-              <c16:uniqueId val="{00000003-71F5-44E4-B04C-150C520960BF}"/>
+              <c16:uniqueId val="{00000003-6A69-49CC-A284-C75A47A4598D}"/>
             </c:ext>
           </c:extLst>
         </c:ser>
@@ -1710,11 +2139,11 @@
             </c:spPr>
           </c:downBars>
         </c:upDownBars>
-        <c:axId val="1448273360"/>
-        <c:axId val="1019240720"/>
+        <c:axId val="1452859872"/>
+        <c:axId val="1019395760"/>
       </c:stockChart>
       <c:catAx>
-        <c:axId val="1448273360"/>
+        <c:axId val="1452859872"/>
         <c:scaling>
           <c:orientation val="minMax"/>
         </c:scaling>
@@ -1757,7 +2186,7 @@
             <a:endParaRPr lang="de-DE"/>
           </a:p>
         </c:txPr>
-        <c:crossAx val="1019240720"/>
+        <c:crossAx val="1019395760"/>
         <c:crosses val="autoZero"/>
         <c:auto val="1"/>
         <c:lblAlgn val="ctr"/>
@@ -1765,7 +2194,7 @@
         <c:noMultiLvlLbl val="0"/>
       </c:catAx>
       <c:valAx>
-        <c:axId val="1019240720"/>
+        <c:axId val="1019395760"/>
         <c:scaling>
           <c:orientation val="minMax"/>
         </c:scaling>
@@ -1816,7 +2245,7 @@
             <a:endParaRPr lang="de-DE"/>
           </a:p>
         </c:txPr>
-        <c:crossAx val="1448273360"/>
+        <c:crossAx val="1452859872"/>
         <c:crosses val="autoZero"/>
         <c:crossBetween val="between"/>
       </c:valAx>
@@ -2016,7 +2445,7 @@
           </c:val>
           <c:extLst>
             <c:ext xmlns:c16="http://schemas.microsoft.com/office/drawing/2014/chart" uri="{C3380CC4-5D6E-409C-BE32-E72D297353CC}">
-              <c16:uniqueId val="{00000000-89B3-4DE2-A64D-AD4A54D5D960}"/>
+              <c16:uniqueId val="{00000000-AC5E-4EC6-BD89-9134109D932F}"/>
             </c:ext>
           </c:extLst>
         </c:ser>
@@ -2085,7 +2514,7 @@
           </c:val>
           <c:extLst>
             <c:ext xmlns:c16="http://schemas.microsoft.com/office/drawing/2014/chart" uri="{C3380CC4-5D6E-409C-BE32-E72D297353CC}">
-              <c16:uniqueId val="{00000001-89B3-4DE2-A64D-AD4A54D5D960}"/>
+              <c16:uniqueId val="{00000001-AC5E-4EC6-BD89-9134109D932F}"/>
             </c:ext>
           </c:extLst>
         </c:ser>
@@ -2154,7 +2583,7 @@
           </c:val>
           <c:extLst>
             <c:ext xmlns:c16="http://schemas.microsoft.com/office/drawing/2014/chart" uri="{C3380CC4-5D6E-409C-BE32-E72D297353CC}">
-              <c16:uniqueId val="{00000002-89B3-4DE2-A64D-AD4A54D5D960}"/>
+              <c16:uniqueId val="{00000002-AC5E-4EC6-BD89-9134109D932F}"/>
             </c:ext>
           </c:extLst>
         </c:ser>
@@ -2346,12 +2775,12 @@
             </c:spPr>
           </c:bandFmt>
         </c:bandFmts>
-        <c:axId val="1448241344"/>
-        <c:axId val="1019244080"/>
-        <c:axId val="1047919456"/>
+        <c:axId val="1452832960"/>
+        <c:axId val="1019478800"/>
+        <c:axId val="1875891632"/>
       </c:surfaceChart>
       <c:catAx>
-        <c:axId val="1448241344"/>
+        <c:axId val="1452832960"/>
         <c:scaling>
           <c:orientation val="minMax"/>
         </c:scaling>
@@ -2394,7 +2823,7 @@
             <a:endParaRPr lang="de-DE"/>
           </a:p>
         </c:txPr>
-        <c:crossAx val="1019244080"/>
+        <c:crossAx val="1019478800"/>
         <c:crosses val="autoZero"/>
         <c:auto val="1"/>
         <c:lblAlgn val="ctr"/>
@@ -2402,7 +2831,7 @@
         <c:noMultiLvlLbl val="0"/>
       </c:catAx>
       <c:valAx>
-        <c:axId val="1019244080"/>
+        <c:axId val="1019478800"/>
         <c:scaling>
           <c:orientation val="minMax"/>
         </c:scaling>
@@ -2453,12 +2882,12 @@
             <a:endParaRPr lang="de-DE"/>
           </a:p>
         </c:txPr>
-        <c:crossAx val="1448241344"/>
+        <c:crossAx val="1452832960"/>
         <c:crosses val="autoZero"/>
         <c:crossBetween val="midCat"/>
       </c:valAx>
       <c:serAx>
-        <c:axId val="1047919456"/>
+        <c:axId val="1875891632"/>
         <c:scaling>
           <c:orientation val="minMax"/>
         </c:scaling>
@@ -2500,7 +2929,7 @@
             <a:endParaRPr lang="de-DE"/>
           </a:p>
         </c:txPr>
-        <c:crossAx val="1019244080"/>
+        <c:crossAx val="1019478800"/>
         <c:crosses val="autoZero"/>
       </c:serAx>
       <c:spPr>
@@ -2733,7 +3162,7 @@
           <c:smooth val="0"/>
           <c:extLst>
             <c:ext xmlns:c16="http://schemas.microsoft.com/office/drawing/2014/chart" uri="{C3380CC4-5D6E-409C-BE32-E72D297353CC}">
-              <c16:uniqueId val="{00000000-1C47-46D0-B6FE-869B4E870571}"/>
+              <c16:uniqueId val="{00000000-1D86-4A49-A768-50D0F4704132}"/>
             </c:ext>
           </c:extLst>
         </c:ser>
@@ -2745,11 +3174,11 @@
           <c:showPercent val="0"/>
           <c:showBubbleSize val="0"/>
         </c:dLbls>
-        <c:axId val="1448249696"/>
-        <c:axId val="1019241200"/>
+        <c:axId val="1452833424"/>
+        <c:axId val="1019224400"/>
       </c:scatterChart>
       <c:valAx>
-        <c:axId val="1448249696"/>
+        <c:axId val="1452833424"/>
         <c:scaling>
           <c:orientation val="minMax"/>
         </c:scaling>
@@ -2806,12 +3235,12 @@
             <a:endParaRPr lang="de-DE"/>
           </a:p>
         </c:txPr>
-        <c:crossAx val="1019241200"/>
+        <c:crossAx val="1019224400"/>
         <c:crosses val="autoZero"/>
         <c:crossBetween val="midCat"/>
       </c:valAx>
       <c:valAx>
-        <c:axId val="1019241200"/>
+        <c:axId val="1019224400"/>
         <c:scaling>
           <c:orientation val="minMax"/>
         </c:scaling>
@@ -2868,7 +3297,7 @@
             <a:endParaRPr lang="de-DE"/>
           </a:p>
         </c:txPr>
-        <c:crossAx val="1448249696"/>
+        <c:crossAx val="1452833424"/>
         <c:crosses val="autoZero"/>
         <c:crossBetween val="midCat"/>
       </c:valAx>
@@ -3055,7 +3484,7 @@
           <c:smooth val="0"/>
           <c:extLst>
             <c:ext xmlns:c16="http://schemas.microsoft.com/office/drawing/2014/chart" uri="{C3380CC4-5D6E-409C-BE32-E72D297353CC}">
-              <c16:uniqueId val="{00000000-F2E5-457A-A84D-6C4CD6B541BD}"/>
+              <c16:uniqueId val="{00000000-F3F8-4665-A764-77AF87F3B70E}"/>
             </c:ext>
           </c:extLst>
         </c:ser>
@@ -3068,11 +3497,11 @@
           <c:showBubbleSize val="0"/>
         </c:dLbls>
         <c:smooth val="0"/>
-        <c:axId val="1448242736"/>
-        <c:axId val="1019254640"/>
+        <c:axId val="1452826928"/>
+        <c:axId val="1019278160"/>
       </c:lineChart>
       <c:catAx>
-        <c:axId val="1448242736"/>
+        <c:axId val="1452826928"/>
         <c:scaling>
           <c:orientation val="minMax"/>
         </c:scaling>
@@ -3115,7 +3544,7 @@
             <a:endParaRPr lang="de-DE"/>
           </a:p>
         </c:txPr>
-        <c:crossAx val="1019254640"/>
+        <c:crossAx val="1019278160"/>
         <c:crosses val="autoZero"/>
         <c:auto val="1"/>
         <c:lblAlgn val="ctr"/>
@@ -3123,7 +3552,7 @@
         <c:noMultiLvlLbl val="0"/>
       </c:catAx>
       <c:valAx>
-        <c:axId val="1019254640"/>
+        <c:axId val="1019278160"/>
         <c:scaling>
           <c:orientation val="minMax"/>
         </c:scaling>
@@ -3174,7 +3603,7 @@
             <a:endParaRPr lang="de-DE"/>
           </a:p>
         </c:txPr>
-        <c:crossAx val="1448242736"/>
+        <c:crossAx val="1452826928"/>
         <c:crosses val="autoZero"/>
         <c:crossBetween val="between"/>
       </c:valAx>
@@ -3339,7 +3768,7 @@
           </c:val>
           <c:extLst>
             <c:ext xmlns:c16="http://schemas.microsoft.com/office/drawing/2014/chart" uri="{C3380CC4-5D6E-409C-BE32-E72D297353CC}">
-              <c16:uniqueId val="{00000000-D4B8-4294-A1C8-D969350DCF2D}"/>
+              <c16:uniqueId val="{00000000-39AB-4035-A181-0E3160C482B4}"/>
             </c:ext>
           </c:extLst>
         </c:ser>
@@ -3410,7 +3839,7 @@
           </c:val>
           <c:extLst>
             <c:ext xmlns:c16="http://schemas.microsoft.com/office/drawing/2014/chart" uri="{C3380CC4-5D6E-409C-BE32-E72D297353CC}">
-              <c16:uniqueId val="{00000001-D4B8-4294-A1C8-D969350DCF2D}"/>
+              <c16:uniqueId val="{00000001-39AB-4035-A181-0E3160C482B4}"/>
             </c:ext>
           </c:extLst>
         </c:ser>
@@ -3481,7 +3910,7 @@
           </c:val>
           <c:extLst>
             <c:ext xmlns:c16="http://schemas.microsoft.com/office/drawing/2014/chart" uri="{C3380CC4-5D6E-409C-BE32-E72D297353CC}">
-              <c16:uniqueId val="{00000002-D4B8-4294-A1C8-D969350DCF2D}"/>
+              <c16:uniqueId val="{00000002-39AB-4035-A181-0E3160C482B4}"/>
             </c:ext>
           </c:extLst>
         </c:ser>
@@ -3495,11 +3924,11 @@
         </c:dLbls>
         <c:gapWidth val="219"/>
         <c:overlap val="-27"/>
-        <c:axId val="1448282640"/>
-        <c:axId val="1019246480"/>
+        <c:axId val="1452840848"/>
+        <c:axId val="1019294480"/>
       </c:barChart>
       <c:catAx>
-        <c:axId val="1448282640"/>
+        <c:axId val="1452840848"/>
         <c:scaling>
           <c:orientation val="minMax"/>
         </c:scaling>
@@ -3542,7 +3971,7 @@
             <a:endParaRPr lang="de-DE"/>
           </a:p>
         </c:txPr>
-        <c:crossAx val="1019246480"/>
+        <c:crossAx val="1019294480"/>
         <c:crosses val="autoZero"/>
         <c:auto val="1"/>
         <c:lblAlgn val="ctr"/>
@@ -3550,7 +3979,7 @@
         <c:noMultiLvlLbl val="0"/>
       </c:catAx>
       <c:valAx>
-        <c:axId val="1019246480"/>
+        <c:axId val="1019294480"/>
         <c:scaling>
           <c:orientation val="minMax"/>
         </c:scaling>
@@ -3601,7 +4030,7 @@
             <a:endParaRPr lang="de-DE"/>
           </a:p>
         </c:txPr>
-        <c:crossAx val="1448282640"/>
+        <c:crossAx val="1452840848"/>
         <c:crosses val="autoZero"/>
         <c:crossBetween val="between"/>
       </c:valAx>
@@ -3819,7 +4248,7 @@
           <c:bubble3D val="0"/>
           <c:extLst>
             <c:ext xmlns:c16="http://schemas.microsoft.com/office/drawing/2014/chart" uri="{C3380CC4-5D6E-409C-BE32-E72D297353CC}">
-              <c16:uniqueId val="{00000000-6C3F-4EBB-A6B1-0D7727CB14F7}"/>
+              <c16:uniqueId val="{00000000-9D47-4ACC-98F8-438F1A65D116}"/>
             </c:ext>
           </c:extLst>
         </c:ser>
@@ -3833,11 +4262,11 @@
         </c:dLbls>
         <c:bubbleScale val="100"/>
         <c:showNegBubbles val="0"/>
-        <c:axId val="1448272896"/>
-        <c:axId val="1019244560"/>
+        <c:axId val="1452850128"/>
+        <c:axId val="1019288720"/>
       </c:bubbleChart>
       <c:valAx>
-        <c:axId val="1448272896"/>
+        <c:axId val="1452850128"/>
         <c:scaling>
           <c:orientation val="minMax"/>
         </c:scaling>
@@ -3894,12 +4323,12 @@
             <a:endParaRPr lang="de-DE"/>
           </a:p>
         </c:txPr>
-        <c:crossAx val="1019244560"/>
+        <c:crossAx val="1019288720"/>
         <c:crosses val="autoZero"/>
         <c:crossBetween val="midCat"/>
       </c:valAx>
       <c:valAx>
-        <c:axId val="1019244560"/>
+        <c:axId val="1019288720"/>
         <c:scaling>
           <c:orientation val="minMax"/>
         </c:scaling>
@@ -3956,7 +4385,7 @@
             <a:endParaRPr lang="de-DE"/>
           </a:p>
         </c:txPr>
-        <c:crossAx val="1448272896"/>
+        <c:crossAx val="1452850128"/>
         <c:crosses val="autoZero"/>
         <c:crossBetween val="midCat"/>
       </c:valAx>
@@ -4067,7 +4496,7 @@
     <cx:title pos="t" align="ctr" overlay="0"/>
     <cx:plotArea>
       <cx:plotAreaRegion>
-        <cx:series layoutId="waterfall" uniqueId="{C7E0F5AC-94B1-48DF-9775-C751DCADF5B3}">
+        <cx:series layoutId="waterfall" uniqueId="{C2A95130-05C1-465E-A5AD-301C7E8B46F6}">
           <cx:dataLabels pos="outEnd">
             <cx:visibility seriesName="0" categoryName="0" value="1"/>
           </cx:dataLabels>
@@ -4124,7 +4553,7 @@
     <cx:title pos="t" align="ctr" overlay="0"/>
     <cx:plotArea>
       <cx:plotAreaRegion>
-        <cx:series layoutId="funnel" uniqueId="{293AA666-5237-46C1-8BAC-281F3E7FBF93}">
+        <cx:series layoutId="funnel" uniqueId="{8DC2DFB9-7856-4BF0-B809-E0264A97324C}">
           <cx:dataLabels>
             <cx:visibility seriesName="0" categoryName="0" value="1"/>
           </cx:dataLabels>
@@ -4230,7 +4659,7 @@
     <cx:title pos="t" align="ctr" overlay="0"/>
     <cx:plotArea>
       <cx:plotAreaRegion>
-        <cx:series layoutId="clusteredColumn" uniqueId="{500F2C03-7F88-4CE6-8FEA-BDF072AF7641}">
+        <cx:series layoutId="clusteredColumn" uniqueId="{F01A22F9-BB40-493A-831E-7917CF1297EC}">
           <cx:dataId val="0"/>
           <cx:layoutPr>
             <cx:binning intervalClosed="r"/>
@@ -4337,7 +4766,7 @@
     <cx:title pos="t" align="ctr" overlay="0"/>
     <cx:plotArea>
       <cx:plotAreaRegion>
-        <cx:series layoutId="treemap" uniqueId="{A17FE18C-378E-4E27-980D-1EBDA4C73AA2}">
+        <cx:series layoutId="treemap" uniqueId="{1E8888B7-1E77-44EA-8587-287B5211404D}">
           <cx:dataLabels pos="inEnd">
             <cx:visibility seriesName="0" categoryName="1" value="0"/>
           </cx:dataLabels>
@@ -4439,7 +4868,7 @@
     <cx:title pos="t" align="ctr" overlay="0"/>
     <cx:plotArea>
       <cx:plotAreaRegion>
-        <cx:series layoutId="sunburst" uniqueId="{A36EAA78-1311-4440-A8A5-DE305F22CDDB}">
+        <cx:series layoutId="sunburst" uniqueId="{BD2A7FE3-27F3-483D-A81C-05676269C340}">
           <cx:dataLabels pos="ctr">
             <cx:visibility seriesName="0" categoryName="1" value="0"/>
           </cx:dataLabels>
@@ -4621,21 +5050,21 @@
     <cx:title pos="t" align="ctr" overlay="0"/>
     <cx:plotArea>
       <cx:plotAreaRegion>
-        <cx:series layoutId="boxWhisker" uniqueId="{C5BBAB38-5533-42C1-949A-728F6BFBE7EF}">
+        <cx:series layoutId="boxWhisker" uniqueId="{3B8F9B67-29CF-42FD-9801-0ED123DAE514}">
           <cx:dataId val="0"/>
           <cx:layoutPr>
             <cx:visibility meanLine="0" meanMarker="1" nonoutliers="0" outliers="1"/>
             <cx:statistics quartileMethod="exclusive"/>
           </cx:layoutPr>
         </cx:series>
-        <cx:series layoutId="boxWhisker" uniqueId="{B5195A0C-DCF0-4F75-A79F-1C7E56D8AB5D}">
+        <cx:series layoutId="boxWhisker" uniqueId="{27512062-5188-4055-BEC6-DF819EDCF3B9}">
           <cx:dataId val="1"/>
           <cx:layoutPr>
             <cx:visibility meanLine="0" meanMarker="1" nonoutliers="0" outliers="1"/>
             <cx:statistics quartileMethod="exclusive"/>
           </cx:layoutPr>
         </cx:series>
-        <cx:series layoutId="boxWhisker" uniqueId="{E7C60E20-4E9B-4B59-A836-C4F67A05BFAB}">
+        <cx:series layoutId="boxWhisker" uniqueId="{9F4D38CB-6639-49B9-ADA6-B631004628EF}">
           <cx:dataId val="2"/>
           <cx:layoutPr>
             <cx:visibility meanLine="0" meanMarker="1" nonoutliers="0" outliers="1"/>
@@ -4858,6 +5287,46 @@
 </file>
 
 <file path=ppt/charts/colors14.xml><?xml version="1.0" encoding="utf-8"?>
+<cs:colorStyle xmlns:cs="http://schemas.microsoft.com/office/drawing/2012/chartStyle" xmlns:a="http://schemas.openxmlformats.org/drawingml/2006/main" meth="cycle" id="10">
+  <a:schemeClr val="accent1"/>
+  <a:schemeClr val="accent2"/>
+  <a:schemeClr val="accent3"/>
+  <a:schemeClr val="accent4"/>
+  <a:schemeClr val="accent5"/>
+  <a:schemeClr val="accent6"/>
+  <cs:variation/>
+  <cs:variation>
+    <a:lumMod val="60000"/>
+  </cs:variation>
+  <cs:variation>
+    <a:lumMod val="80000"/>
+    <a:lumOff val="20000"/>
+  </cs:variation>
+  <cs:variation>
+    <a:lumMod val="80000"/>
+  </cs:variation>
+  <cs:variation>
+    <a:lumMod val="60000"/>
+    <a:lumOff val="40000"/>
+  </cs:variation>
+  <cs:variation>
+    <a:lumMod val="50000"/>
+  </cs:variation>
+  <cs:variation>
+    <a:lumMod val="70000"/>
+    <a:lumOff val="30000"/>
+  </cs:variation>
+  <cs:variation>
+    <a:lumMod val="70000"/>
+  </cs:variation>
+  <cs:variation>
+    <a:lumMod val="50000"/>
+    <a:lumOff val="50000"/>
+  </cs:variation>
+</cs:colorStyle>
+</file>
+
+<file path=ppt/charts/colors15.xml><?xml version="1.0" encoding="utf-8"?>
 <cs:colorStyle xmlns:cs="http://schemas.microsoft.com/office/drawing/2012/chartStyle" xmlns:a="http://schemas.openxmlformats.org/drawingml/2006/main" meth="cycle" id="10">
   <a:schemeClr val="accent1"/>
   <a:schemeClr val="accent2"/>
@@ -8285,8 +8754,8 @@
 </cs:chartStyle>
 </file>
 
-<file path=ppt/charts/style2.xml><?xml version="1.0" encoding="utf-8"?>
-<cs:chartStyle xmlns:cs="http://schemas.microsoft.com/office/drawing/2012/chartStyle" xmlns:a="http://schemas.openxmlformats.org/drawingml/2006/main" id="317">
+<file path=ppt/charts/style15.xml><?xml version="1.0" encoding="utf-8"?>
+<cs:chartStyle xmlns:cs="http://schemas.microsoft.com/office/drawing/2012/chartStyle" xmlns:a="http://schemas.openxmlformats.org/drawingml/2006/main" id="201">
   <cs:axisTitle>
     <cs:lnRef idx="0"/>
     <cs:fillRef idx="0"/>
@@ -8490,23 +8959,22 @@
     <cs:fillRef idx="0"/>
     <cs:effectRef idx="0"/>
     <cs:fontRef idx="minor">
-      <a:schemeClr val="tx1"/>
+      <a:schemeClr val="dk1"/>
     </cs:fontRef>
     <cs:spPr>
       <a:solidFill>
         <a:schemeClr val="dk1">
-          <a:lumMod val="75000"/>
-          <a:lumOff val="25000"/>
+          <a:lumMod val="65000"/>
+          <a:lumOff val="35000"/>
         </a:schemeClr>
       </a:solidFill>
-      <a:ln w="9525" cap="flat" cmpd="sng" algn="ctr">
+      <a:ln w="9525">
         <a:solidFill>
           <a:schemeClr val="tx1">
             <a:lumMod val="65000"/>
             <a:lumOff val="35000"/>
           </a:schemeClr>
         </a:solidFill>
-        <a:round/>
       </a:ln>
     </cs:spPr>
   </cs:downBar>
@@ -8611,8 +9079,8 @@
       <a:ln w="9525" cap="flat" cmpd="sng" algn="ctr">
         <a:solidFill>
           <a:schemeClr val="tx1">
-            <a:lumMod val="50000"/>
-            <a:lumOff val="50000"/>
+            <a:lumMod val="75000"/>
+            <a:lumOff val="25000"/>
           </a:schemeClr>
         </a:solidFill>
         <a:round/>
@@ -8744,20 +9212,19 @@
     <cs:fillRef idx="0"/>
     <cs:effectRef idx="0"/>
     <cs:fontRef idx="minor">
-      <a:schemeClr val="tx1"/>
+      <a:schemeClr val="dk1"/>
     </cs:fontRef>
     <cs:spPr>
       <a:solidFill>
         <a:schemeClr val="lt1"/>
       </a:solidFill>
-      <a:ln w="9525" cap="flat" cmpd="sng" algn="ctr">
-        <a:solidFill>
-          <a:schemeClr val="tx1">
-            <a:lumMod val="65000"/>
-            <a:lumOff val="35000"/>
-          </a:schemeClr>
-        </a:solidFill>
-        <a:round/>
+      <a:ln w="9525">
+        <a:solidFill>
+          <a:schemeClr val="tx1">
+            <a:lumMod val="15000"/>
+            <a:lumOff val="85000"/>
+          </a:schemeClr>
+        </a:solidFill>
       </a:ln>
     </cs:spPr>
   </cs:upBar>
@@ -8790,8 +9257,8 @@
 </cs:chartStyle>
 </file>
 
-<file path=ppt/charts/style3.xml><?xml version="1.0" encoding="utf-8"?>
-<cs:chartStyle xmlns:cs="http://schemas.microsoft.com/office/drawing/2012/chartStyle" xmlns:a="http://schemas.openxmlformats.org/drawingml/2006/main" id="322">
+<file path=ppt/charts/style2.xml><?xml version="1.0" encoding="utf-8"?>
+<cs:chartStyle xmlns:cs="http://schemas.microsoft.com/office/drawing/2012/chartStyle" xmlns:a="http://schemas.openxmlformats.org/drawingml/2006/main" id="317">
   <cs:axisTitle>
     <cs:lnRef idx="0"/>
     <cs:fillRef idx="0"/>
@@ -9116,8 +9583,8 @@
       <a:ln w="9525" cap="flat" cmpd="sng" algn="ctr">
         <a:solidFill>
           <a:schemeClr val="tx1">
-            <a:lumMod val="75000"/>
-            <a:lumOff val="25000"/>
+            <a:lumMod val="50000"/>
+            <a:lumOff val="50000"/>
           </a:schemeClr>
         </a:solidFill>
         <a:round/>
@@ -9181,17 +9648,6 @@
         <a:lumOff val="35000"/>
       </a:schemeClr>
     </cs:fontRef>
-    <cs:spPr>
-      <a:ln w="9525" cap="flat" cmpd="sng" algn="ctr">
-        <a:solidFill>
-          <a:schemeClr val="tx1">
-            <a:lumMod val="15000"/>
-            <a:lumOff val="85000"/>
-          </a:schemeClr>
-        </a:solidFill>
-        <a:round/>
-      </a:ln>
-    </cs:spPr>
     <cs:defRPr sz="1197" kern="1200"/>
   </cs:seriesAxis>
   <cs:seriesLine>
@@ -9306,7 +9762,7 @@
 </cs:chartStyle>
 </file>
 
-<file path=ppt/charts/style4.xml><?xml version="1.0" encoding="utf-8"?>
+<file path=ppt/charts/style3.xml><?xml version="1.0" encoding="utf-8"?>
 <cs:chartStyle xmlns:cs="http://schemas.microsoft.com/office/drawing/2012/chartStyle" xmlns:a="http://schemas.openxmlformats.org/drawingml/2006/main" id="322">
   <cs:axisTitle>
     <cs:lnRef idx="0"/>
@@ -9822,8 +10278,8 @@
 </cs:chartStyle>
 </file>
 
-<file path=ppt/charts/style5.xml><?xml version="1.0" encoding="utf-8"?>
-<cs:chartStyle xmlns:cs="http://schemas.microsoft.com/office/drawing/2012/chartStyle" xmlns:a="http://schemas.openxmlformats.org/drawingml/2006/main" id="240">
+<file path=ppt/charts/style4.xml><?xml version="1.0" encoding="utf-8"?>
+<cs:chartStyle xmlns:cs="http://schemas.microsoft.com/office/drawing/2012/chartStyle" xmlns:a="http://schemas.openxmlformats.org/drawingml/2006/main" id="322">
   <cs:axisTitle>
     <cs:lnRef idx="0"/>
     <cs:fillRef idx="0"/>
@@ -9850,8 +10306,8 @@
       <a:ln w="9525" cap="flat" cmpd="sng" algn="ctr">
         <a:solidFill>
           <a:schemeClr val="tx1">
-            <a:lumMod val="25000"/>
-            <a:lumOff val="75000"/>
+            <a:lumMod val="15000"/>
+            <a:lumOff val="85000"/>
           </a:schemeClr>
         </a:solidFill>
         <a:round/>
@@ -9952,7 +10408,7 @@
       <a:schemeClr val="tx1"/>
     </cs:fontRef>
     <cs:spPr>
-      <a:ln w="19050" cap="rnd">
+      <a:ln w="28575" cap="rnd">
         <a:solidFill>
           <a:schemeClr val="phClr"/>
         </a:solidFill>
@@ -9984,10 +10440,10 @@
     <cs:lnRef idx="0">
       <cs:styleClr val="auto"/>
     </cs:lnRef>
-    <cs:fillRef idx="0"/>
-    <cs:effectRef idx="0"/>
-    <cs:fontRef idx="minor">
-      <a:schemeClr val="dk1"/>
+    <cs:fillRef idx="1"/>
+    <cs:effectRef idx="0"/>
+    <cs:fontRef idx="minor">
+      <a:schemeClr val="tx1"/>
     </cs:fontRef>
     <cs:spPr>
       <a:ln w="9525" cap="rnd">
@@ -10148,8 +10604,8 @@
       <a:ln w="9525" cap="flat" cmpd="sng" algn="ctr">
         <a:solidFill>
           <a:schemeClr val="tx1">
-            <a:lumMod val="50000"/>
-            <a:lumOff val="50000"/>
+            <a:lumMod val="75000"/>
+            <a:lumOff val="25000"/>
           </a:schemeClr>
         </a:solidFill>
         <a:round/>
@@ -10213,6 +10669,17 @@
         <a:lumOff val="35000"/>
       </a:schemeClr>
     </cs:fontRef>
+    <cs:spPr>
+      <a:ln w="9525" cap="flat" cmpd="sng" algn="ctr">
+        <a:solidFill>
+          <a:schemeClr val="tx1">
+            <a:lumMod val="15000"/>
+            <a:lumOff val="85000"/>
+          </a:schemeClr>
+        </a:solidFill>
+        <a:round/>
+      </a:ln>
+    </cs:spPr>
     <cs:defRPr sz="1197" kern="1200"/>
   </cs:seriesAxis>
   <cs:seriesLine>
@@ -10308,17 +10775,6 @@
         <a:lumOff val="35000"/>
       </a:schemeClr>
     </cs:fontRef>
-    <cs:spPr>
-      <a:ln w="9525" cap="flat" cmpd="sng" algn="ctr">
-        <a:solidFill>
-          <a:schemeClr val="tx1">
-            <a:lumMod val="25000"/>
-            <a:lumOff val="75000"/>
-          </a:schemeClr>
-        </a:solidFill>
-        <a:round/>
-      </a:ln>
-    </cs:spPr>
     <cs:defRPr sz="1197" kern="1200"/>
   </cs:valueAxis>
   <cs:wall>
@@ -10338,8 +10794,8 @@
 </cs:chartStyle>
 </file>
 
-<file path=ppt/charts/style6.xml><?xml version="1.0" encoding="utf-8"?>
-<cs:chartStyle xmlns:cs="http://schemas.microsoft.com/office/drawing/2012/chartStyle" xmlns:a="http://schemas.openxmlformats.org/drawingml/2006/main" id="227">
+<file path=ppt/charts/style5.xml><?xml version="1.0" encoding="utf-8"?>
+<cs:chartStyle xmlns:cs="http://schemas.microsoft.com/office/drawing/2012/chartStyle" xmlns:a="http://schemas.openxmlformats.org/drawingml/2006/main" id="240">
   <cs:axisTitle>
     <cs:lnRef idx="0"/>
     <cs:fillRef idx="0"/>
@@ -10366,8 +10822,8 @@
       <a:ln w="9525" cap="flat" cmpd="sng" algn="ctr">
         <a:solidFill>
           <a:schemeClr val="tx1">
-            <a:lumMod val="15000"/>
-            <a:lumOff val="85000"/>
+            <a:lumMod val="25000"/>
+            <a:lumOff val="75000"/>
           </a:schemeClr>
         </a:solidFill>
         <a:round/>
@@ -10447,11 +10903,6 @@
     <cs:fontRef idx="minor">
       <a:schemeClr val="tx1"/>
     </cs:fontRef>
-    <cs:spPr>
-      <a:solidFill>
-        <a:schemeClr val="phClr"/>
-      </a:solidFill>
-    </cs:spPr>
   </cs:dataPoint>
   <cs:dataPoint3D>
     <cs:lnRef idx="0"/>
@@ -10462,11 +10913,6 @@
     <cs:fontRef idx="minor">
       <a:schemeClr val="tx1"/>
     </cs:fontRef>
-    <cs:spPr>
-      <a:solidFill>
-        <a:schemeClr val="phClr"/>
-      </a:solidFill>
-    </cs:spPr>
   </cs:dataPoint3D>
   <cs:dataPointLine>
     <cs:lnRef idx="0">
@@ -10478,7 +10924,7 @@
       <a:schemeClr val="tx1"/>
     </cs:fontRef>
     <cs:spPr>
-      <a:ln w="28575" cap="rnd">
+      <a:ln w="19050" cap="rnd">
         <a:solidFill>
           <a:schemeClr val="phClr"/>
         </a:solidFill>
@@ -10498,9 +10944,6 @@
       <a:schemeClr val="tx1"/>
     </cs:fontRef>
     <cs:spPr>
-      <a:solidFill>
-        <a:schemeClr val="phClr"/>
-      </a:solidFill>
       <a:ln w="9525">
         <a:solidFill>
           <a:schemeClr val="phClr"/>
@@ -10513,10 +10956,10 @@
     <cs:lnRef idx="0">
       <cs:styleClr val="auto"/>
     </cs:lnRef>
-    <cs:fillRef idx="1"/>
-    <cs:effectRef idx="0"/>
-    <cs:fontRef idx="minor">
-      <a:schemeClr val="tx1"/>
+    <cs:fillRef idx="0"/>
+    <cs:effectRef idx="0"/>
+    <cs:fontRef idx="minor">
+      <a:schemeClr val="dk1"/>
     </cs:fontRef>
     <cs:spPr>
       <a:ln w="9525" cap="rnd">
@@ -10556,22 +10999,23 @@
     <cs:fillRef idx="0"/>
     <cs:effectRef idx="0"/>
     <cs:fontRef idx="minor">
-      <a:schemeClr val="dk1"/>
+      <a:schemeClr val="tx1"/>
     </cs:fontRef>
     <cs:spPr>
       <a:solidFill>
         <a:schemeClr val="dk1">
-          <a:lumMod val="65000"/>
-          <a:lumOff val="35000"/>
+          <a:lumMod val="75000"/>
+          <a:lumOff val="25000"/>
         </a:schemeClr>
       </a:solidFill>
-      <a:ln w="9525">
+      <a:ln w="9525" cap="flat" cmpd="sng" algn="ctr">
         <a:solidFill>
           <a:schemeClr val="tx1">
             <a:lumMod val="65000"/>
             <a:lumOff val="35000"/>
           </a:schemeClr>
         </a:solidFill>
+        <a:round/>
       </a:ln>
     </cs:spPr>
   </cs:downBar>
@@ -10676,8 +11120,8 @@
       <a:ln w="9525" cap="flat" cmpd="sng" algn="ctr">
         <a:solidFill>
           <a:schemeClr val="tx1">
-            <a:lumMod val="75000"/>
-            <a:lumOff val="25000"/>
+            <a:lumMod val="50000"/>
+            <a:lumOff val="50000"/>
           </a:schemeClr>
         </a:solidFill>
         <a:round/>
@@ -10809,19 +11253,20 @@
     <cs:fillRef idx="0"/>
     <cs:effectRef idx="0"/>
     <cs:fontRef idx="minor">
-      <a:schemeClr val="dk1"/>
+      <a:schemeClr val="tx1"/>
     </cs:fontRef>
     <cs:spPr>
       <a:solidFill>
         <a:schemeClr val="lt1"/>
       </a:solidFill>
-      <a:ln w="9525">
-        <a:solidFill>
-          <a:schemeClr val="tx1">
-            <a:lumMod val="15000"/>
-            <a:lumOff val="85000"/>
-          </a:schemeClr>
-        </a:solidFill>
+      <a:ln w="9525" cap="flat" cmpd="sng" algn="ctr">
+        <a:solidFill>
+          <a:schemeClr val="tx1">
+            <a:lumMod val="65000"/>
+            <a:lumOff val="35000"/>
+          </a:schemeClr>
+        </a:solidFill>
+        <a:round/>
       </a:ln>
     </cs:spPr>
   </cs:upBar>
@@ -10835,6 +11280,17 @@
         <a:lumOff val="35000"/>
       </a:schemeClr>
     </cs:fontRef>
+    <cs:spPr>
+      <a:ln w="9525" cap="flat" cmpd="sng" algn="ctr">
+        <a:solidFill>
+          <a:schemeClr val="tx1">
+            <a:lumMod val="25000"/>
+            <a:lumOff val="75000"/>
+          </a:schemeClr>
+        </a:solidFill>
+        <a:round/>
+      </a:ln>
+    </cs:spPr>
     <cs:defRPr sz="1197" kern="1200"/>
   </cs:valueAxis>
   <cs:wall>
@@ -10854,8 +11310,8 @@
 </cs:chartStyle>
 </file>
 
-<file path=ppt/charts/style7.xml><?xml version="1.0" encoding="utf-8"?>
-<cs:chartStyle xmlns:cs="http://schemas.microsoft.com/office/drawing/2012/chartStyle" xmlns:a="http://schemas.openxmlformats.org/drawingml/2006/main" id="201">
+<file path=ppt/charts/style6.xml><?xml version="1.0" encoding="utf-8"?>
+<cs:chartStyle xmlns:cs="http://schemas.microsoft.com/office/drawing/2012/chartStyle" xmlns:a="http://schemas.openxmlformats.org/drawingml/2006/main" id="227">
   <cs:axisTitle>
     <cs:lnRef idx="0"/>
     <cs:fillRef idx="0"/>
@@ -10963,6 +11419,11 @@
     <cs:fontRef idx="minor">
       <a:schemeClr val="tx1"/>
     </cs:fontRef>
+    <cs:spPr>
+      <a:solidFill>
+        <a:schemeClr val="phClr"/>
+      </a:solidFill>
+    </cs:spPr>
   </cs:dataPoint>
   <cs:dataPoint3D>
     <cs:lnRef idx="0"/>
@@ -10973,6 +11434,11 @@
     <cs:fontRef idx="minor">
       <a:schemeClr val="tx1"/>
     </cs:fontRef>
+    <cs:spPr>
+      <a:solidFill>
+        <a:schemeClr val="phClr"/>
+      </a:solidFill>
+    </cs:spPr>
   </cs:dataPoint3D>
   <cs:dataPointLine>
     <cs:lnRef idx="0">
@@ -11004,6 +11470,9 @@
       <a:schemeClr val="tx1"/>
     </cs:fontRef>
     <cs:spPr>
+      <a:solidFill>
+        <a:schemeClr val="phClr"/>
+      </a:solidFill>
       <a:ln w="9525">
         <a:solidFill>
           <a:schemeClr val="phClr"/>
@@ -11357,8 +11826,8 @@
 </cs:chartStyle>
 </file>
 
-<file path=ppt/charts/style8.xml><?xml version="1.0" encoding="utf-8"?>
-<cs:chartStyle xmlns:cs="http://schemas.microsoft.com/office/drawing/2012/chartStyle" xmlns:a="http://schemas.openxmlformats.org/drawingml/2006/main" id="269">
+<file path=ppt/charts/style7.xml><?xml version="1.0" encoding="utf-8"?>
+<cs:chartStyle xmlns:cs="http://schemas.microsoft.com/office/drawing/2012/chartStyle" xmlns:a="http://schemas.openxmlformats.org/drawingml/2006/main" id="201">
   <cs:axisTitle>
     <cs:lnRef idx="0"/>
     <cs:fillRef idx="0"/>
@@ -11385,8 +11854,8 @@
       <a:ln w="9525" cap="flat" cmpd="sng" algn="ctr">
         <a:solidFill>
           <a:schemeClr val="tx1">
-            <a:lumMod val="25000"/>
-            <a:lumOff val="75000"/>
+            <a:lumMod val="15000"/>
+            <a:lumOff val="85000"/>
           </a:schemeClr>
         </a:solidFill>
         <a:round/>
@@ -11466,13 +11935,6 @@
     <cs:fontRef idx="minor">
       <a:schemeClr val="tx1"/>
     </cs:fontRef>
-    <cs:spPr>
-      <a:solidFill>
-        <a:schemeClr val="phClr">
-          <a:alpha val="75000"/>
-        </a:schemeClr>
-      </a:solidFill>
-    </cs:spPr>
   </cs:dataPoint>
   <cs:dataPoint3D>
     <cs:lnRef idx="0"/>
@@ -11483,13 +11945,6 @@
     <cs:fontRef idx="minor">
       <a:schemeClr val="tx1"/>
     </cs:fontRef>
-    <cs:spPr>
-      <a:solidFill>
-        <a:schemeClr val="phClr">
-          <a:alpha val="75000"/>
-        </a:schemeClr>
-      </a:solidFill>
-    </cs:spPr>
   </cs:dataPoint3D>
   <cs:dataPointLine>
     <cs:lnRef idx="0">
@@ -11501,11 +11956,9 @@
       <a:schemeClr val="tx1"/>
     </cs:fontRef>
     <cs:spPr>
-      <a:ln w="19050" cap="rnd">
-        <a:solidFill>
-          <a:schemeClr val="phClr">
-            <a:alpha val="50000"/>
-          </a:schemeClr>
+      <a:ln w="28575" cap="rnd">
+        <a:solidFill>
+          <a:schemeClr val="phClr"/>
         </a:solidFill>
         <a:round/>
       </a:ln>
@@ -11523,6 +11976,525 @@
       <a:schemeClr val="tx1"/>
     </cs:fontRef>
     <cs:spPr>
+      <a:ln w="9525">
+        <a:solidFill>
+          <a:schemeClr val="phClr"/>
+        </a:solidFill>
+      </a:ln>
+    </cs:spPr>
+  </cs:dataPointMarker>
+  <cs:dataPointMarkerLayout symbol="circle" size="5"/>
+  <cs:dataPointWireframe>
+    <cs:lnRef idx="0">
+      <cs:styleClr val="auto"/>
+    </cs:lnRef>
+    <cs:fillRef idx="1"/>
+    <cs:effectRef idx="0"/>
+    <cs:fontRef idx="minor">
+      <a:schemeClr val="tx1"/>
+    </cs:fontRef>
+    <cs:spPr>
+      <a:ln w="9525" cap="rnd">
+        <a:solidFill>
+          <a:schemeClr val="phClr"/>
+        </a:solidFill>
+        <a:round/>
+      </a:ln>
+    </cs:spPr>
+  </cs:dataPointWireframe>
+  <cs:dataTable>
+    <cs:lnRef idx="0"/>
+    <cs:fillRef idx="0"/>
+    <cs:effectRef idx="0"/>
+    <cs:fontRef idx="minor">
+      <a:schemeClr val="tx1">
+        <a:lumMod val="65000"/>
+        <a:lumOff val="35000"/>
+      </a:schemeClr>
+    </cs:fontRef>
+    <cs:spPr>
+      <a:noFill/>
+      <a:ln w="9525" cap="flat" cmpd="sng" algn="ctr">
+        <a:solidFill>
+          <a:schemeClr val="tx1">
+            <a:lumMod val="15000"/>
+            <a:lumOff val="85000"/>
+          </a:schemeClr>
+        </a:solidFill>
+        <a:round/>
+      </a:ln>
+    </cs:spPr>
+    <cs:defRPr sz="1197" kern="1200"/>
+  </cs:dataTable>
+  <cs:downBar>
+    <cs:lnRef idx="0"/>
+    <cs:fillRef idx="0"/>
+    <cs:effectRef idx="0"/>
+    <cs:fontRef idx="minor">
+      <a:schemeClr val="dk1"/>
+    </cs:fontRef>
+    <cs:spPr>
+      <a:solidFill>
+        <a:schemeClr val="dk1">
+          <a:lumMod val="65000"/>
+          <a:lumOff val="35000"/>
+        </a:schemeClr>
+      </a:solidFill>
+      <a:ln w="9525">
+        <a:solidFill>
+          <a:schemeClr val="tx1">
+            <a:lumMod val="65000"/>
+            <a:lumOff val="35000"/>
+          </a:schemeClr>
+        </a:solidFill>
+      </a:ln>
+    </cs:spPr>
+  </cs:downBar>
+  <cs:dropLine>
+    <cs:lnRef idx="0"/>
+    <cs:fillRef idx="0"/>
+    <cs:effectRef idx="0"/>
+    <cs:fontRef idx="minor">
+      <a:schemeClr val="tx1"/>
+    </cs:fontRef>
+    <cs:spPr>
+      <a:ln w="9525" cap="flat" cmpd="sng" algn="ctr">
+        <a:solidFill>
+          <a:schemeClr val="tx1">
+            <a:lumMod val="35000"/>
+            <a:lumOff val="65000"/>
+          </a:schemeClr>
+        </a:solidFill>
+        <a:round/>
+      </a:ln>
+    </cs:spPr>
+  </cs:dropLine>
+  <cs:errorBar>
+    <cs:lnRef idx="0"/>
+    <cs:fillRef idx="0"/>
+    <cs:effectRef idx="0"/>
+    <cs:fontRef idx="minor">
+      <a:schemeClr val="tx1"/>
+    </cs:fontRef>
+    <cs:spPr>
+      <a:ln w="9525" cap="flat" cmpd="sng" algn="ctr">
+        <a:solidFill>
+          <a:schemeClr val="tx1">
+            <a:lumMod val="65000"/>
+            <a:lumOff val="35000"/>
+          </a:schemeClr>
+        </a:solidFill>
+        <a:round/>
+      </a:ln>
+    </cs:spPr>
+  </cs:errorBar>
+  <cs:floor>
+    <cs:lnRef idx="0"/>
+    <cs:fillRef idx="0"/>
+    <cs:effectRef idx="0"/>
+    <cs:fontRef idx="minor">
+      <a:schemeClr val="tx1"/>
+    </cs:fontRef>
+    <cs:spPr>
+      <a:noFill/>
+      <a:ln>
+        <a:noFill/>
+      </a:ln>
+    </cs:spPr>
+  </cs:floor>
+  <cs:gridlineMajor>
+    <cs:lnRef idx="0"/>
+    <cs:fillRef idx="0"/>
+    <cs:effectRef idx="0"/>
+    <cs:fontRef idx="minor">
+      <a:schemeClr val="tx1"/>
+    </cs:fontRef>
+    <cs:spPr>
+      <a:ln w="9525" cap="flat" cmpd="sng" algn="ctr">
+        <a:solidFill>
+          <a:schemeClr val="tx1">
+            <a:lumMod val="15000"/>
+            <a:lumOff val="85000"/>
+          </a:schemeClr>
+        </a:solidFill>
+        <a:round/>
+      </a:ln>
+    </cs:spPr>
+  </cs:gridlineMajor>
+  <cs:gridlineMinor>
+    <cs:lnRef idx="0"/>
+    <cs:fillRef idx="0"/>
+    <cs:effectRef idx="0"/>
+    <cs:fontRef idx="minor">
+      <a:schemeClr val="tx1"/>
+    </cs:fontRef>
+    <cs:spPr>
+      <a:ln w="9525" cap="flat" cmpd="sng" algn="ctr">
+        <a:solidFill>
+          <a:schemeClr val="tx1">
+            <a:lumMod val="5000"/>
+            <a:lumOff val="95000"/>
+          </a:schemeClr>
+        </a:solidFill>
+        <a:round/>
+      </a:ln>
+    </cs:spPr>
+  </cs:gridlineMinor>
+  <cs:hiLoLine>
+    <cs:lnRef idx="0"/>
+    <cs:fillRef idx="0"/>
+    <cs:effectRef idx="0"/>
+    <cs:fontRef idx="minor">
+      <a:schemeClr val="tx1"/>
+    </cs:fontRef>
+    <cs:spPr>
+      <a:ln w="9525" cap="flat" cmpd="sng" algn="ctr">
+        <a:solidFill>
+          <a:schemeClr val="tx1">
+            <a:lumMod val="75000"/>
+            <a:lumOff val="25000"/>
+          </a:schemeClr>
+        </a:solidFill>
+        <a:round/>
+      </a:ln>
+    </cs:spPr>
+  </cs:hiLoLine>
+  <cs:leaderLine>
+    <cs:lnRef idx="0"/>
+    <cs:fillRef idx="0"/>
+    <cs:effectRef idx="0"/>
+    <cs:fontRef idx="minor">
+      <a:schemeClr val="tx1"/>
+    </cs:fontRef>
+    <cs:spPr>
+      <a:ln w="9525" cap="flat" cmpd="sng" algn="ctr">
+        <a:solidFill>
+          <a:schemeClr val="tx1">
+            <a:lumMod val="35000"/>
+            <a:lumOff val="65000"/>
+          </a:schemeClr>
+        </a:solidFill>
+        <a:round/>
+      </a:ln>
+    </cs:spPr>
+  </cs:leaderLine>
+  <cs:legend>
+    <cs:lnRef idx="0"/>
+    <cs:fillRef idx="0"/>
+    <cs:effectRef idx="0"/>
+    <cs:fontRef idx="minor">
+      <a:schemeClr val="tx1">
+        <a:lumMod val="65000"/>
+        <a:lumOff val="35000"/>
+      </a:schemeClr>
+    </cs:fontRef>
+    <cs:defRPr sz="1197" kern="1200"/>
+  </cs:legend>
+  <cs:plotArea mods="allowNoFillOverride allowNoLineOverride">
+    <cs:lnRef idx="0"/>
+    <cs:fillRef idx="0"/>
+    <cs:effectRef idx="0"/>
+    <cs:fontRef idx="minor">
+      <a:schemeClr val="tx1"/>
+    </cs:fontRef>
+  </cs:plotArea>
+  <cs:plotArea3D mods="allowNoFillOverride allowNoLineOverride">
+    <cs:lnRef idx="0"/>
+    <cs:fillRef idx="0"/>
+    <cs:effectRef idx="0"/>
+    <cs:fontRef idx="minor">
+      <a:schemeClr val="tx1"/>
+    </cs:fontRef>
+  </cs:plotArea3D>
+  <cs:seriesAxis>
+    <cs:lnRef idx="0"/>
+    <cs:fillRef idx="0"/>
+    <cs:effectRef idx="0"/>
+    <cs:fontRef idx="minor">
+      <a:schemeClr val="tx1">
+        <a:lumMod val="65000"/>
+        <a:lumOff val="35000"/>
+      </a:schemeClr>
+    </cs:fontRef>
+    <cs:defRPr sz="1197" kern="1200"/>
+  </cs:seriesAxis>
+  <cs:seriesLine>
+    <cs:lnRef idx="0"/>
+    <cs:fillRef idx="0"/>
+    <cs:effectRef idx="0"/>
+    <cs:fontRef idx="minor">
+      <a:schemeClr val="tx1"/>
+    </cs:fontRef>
+    <cs:spPr>
+      <a:ln w="9525" cap="flat" cmpd="sng" algn="ctr">
+        <a:solidFill>
+          <a:schemeClr val="tx1">
+            <a:lumMod val="35000"/>
+            <a:lumOff val="65000"/>
+          </a:schemeClr>
+        </a:solidFill>
+        <a:round/>
+      </a:ln>
+    </cs:spPr>
+  </cs:seriesLine>
+  <cs:title>
+    <cs:lnRef idx="0"/>
+    <cs:fillRef idx="0"/>
+    <cs:effectRef idx="0"/>
+    <cs:fontRef idx="minor">
+      <a:schemeClr val="tx1">
+        <a:lumMod val="65000"/>
+        <a:lumOff val="35000"/>
+      </a:schemeClr>
+    </cs:fontRef>
+    <cs:defRPr sz="1862" b="0" kern="1200" spc="0" baseline="0"/>
+  </cs:title>
+  <cs:trendline>
+    <cs:lnRef idx="0">
+      <cs:styleClr val="auto"/>
+    </cs:lnRef>
+    <cs:fillRef idx="0"/>
+    <cs:effectRef idx="0"/>
+    <cs:fontRef idx="minor">
+      <a:schemeClr val="tx1"/>
+    </cs:fontRef>
+    <cs:spPr>
+      <a:ln w="19050" cap="rnd">
+        <a:solidFill>
+          <a:schemeClr val="phClr"/>
+        </a:solidFill>
+        <a:prstDash val="sysDot"/>
+      </a:ln>
+    </cs:spPr>
+  </cs:trendline>
+  <cs:trendlineLabel>
+    <cs:lnRef idx="0"/>
+    <cs:fillRef idx="0"/>
+    <cs:effectRef idx="0"/>
+    <cs:fontRef idx="minor">
+      <a:schemeClr val="tx1">
+        <a:lumMod val="65000"/>
+        <a:lumOff val="35000"/>
+      </a:schemeClr>
+    </cs:fontRef>
+    <cs:defRPr sz="1197" kern="1200"/>
+  </cs:trendlineLabel>
+  <cs:upBar>
+    <cs:lnRef idx="0"/>
+    <cs:fillRef idx="0"/>
+    <cs:effectRef idx="0"/>
+    <cs:fontRef idx="minor">
+      <a:schemeClr val="dk1"/>
+    </cs:fontRef>
+    <cs:spPr>
+      <a:solidFill>
+        <a:schemeClr val="lt1"/>
+      </a:solidFill>
+      <a:ln w="9525">
+        <a:solidFill>
+          <a:schemeClr val="tx1">
+            <a:lumMod val="15000"/>
+            <a:lumOff val="85000"/>
+          </a:schemeClr>
+        </a:solidFill>
+      </a:ln>
+    </cs:spPr>
+  </cs:upBar>
+  <cs:valueAxis>
+    <cs:lnRef idx="0"/>
+    <cs:fillRef idx="0"/>
+    <cs:effectRef idx="0"/>
+    <cs:fontRef idx="minor">
+      <a:schemeClr val="tx1">
+        <a:lumMod val="65000"/>
+        <a:lumOff val="35000"/>
+      </a:schemeClr>
+    </cs:fontRef>
+    <cs:defRPr sz="1197" kern="1200"/>
+  </cs:valueAxis>
+  <cs:wall>
+    <cs:lnRef idx="0"/>
+    <cs:fillRef idx="0"/>
+    <cs:effectRef idx="0"/>
+    <cs:fontRef idx="minor">
+      <a:schemeClr val="tx1"/>
+    </cs:fontRef>
+    <cs:spPr>
+      <a:noFill/>
+      <a:ln>
+        <a:noFill/>
+      </a:ln>
+    </cs:spPr>
+  </cs:wall>
+</cs:chartStyle>
+</file>
+
+<file path=ppt/charts/style8.xml><?xml version="1.0" encoding="utf-8"?>
+<cs:chartStyle xmlns:cs="http://schemas.microsoft.com/office/drawing/2012/chartStyle" xmlns:a="http://schemas.openxmlformats.org/drawingml/2006/main" id="269">
+  <cs:axisTitle>
+    <cs:lnRef idx="0"/>
+    <cs:fillRef idx="0"/>
+    <cs:effectRef idx="0"/>
+    <cs:fontRef idx="minor">
+      <a:schemeClr val="tx1">
+        <a:lumMod val="65000"/>
+        <a:lumOff val="35000"/>
+      </a:schemeClr>
+    </cs:fontRef>
+    <cs:defRPr sz="1330" kern="1200"/>
+  </cs:axisTitle>
+  <cs:categoryAxis>
+    <cs:lnRef idx="0"/>
+    <cs:fillRef idx="0"/>
+    <cs:effectRef idx="0"/>
+    <cs:fontRef idx="minor">
+      <a:schemeClr val="tx1">
+        <a:lumMod val="65000"/>
+        <a:lumOff val="35000"/>
+      </a:schemeClr>
+    </cs:fontRef>
+    <cs:spPr>
+      <a:ln w="9525" cap="flat" cmpd="sng" algn="ctr">
+        <a:solidFill>
+          <a:schemeClr val="tx1">
+            <a:lumMod val="25000"/>
+            <a:lumOff val="75000"/>
+          </a:schemeClr>
+        </a:solidFill>
+        <a:round/>
+      </a:ln>
+    </cs:spPr>
+    <cs:defRPr sz="1197" kern="1200"/>
+  </cs:categoryAxis>
+  <cs:chartArea mods="allowNoFillOverride allowNoLineOverride">
+    <cs:lnRef idx="0"/>
+    <cs:fillRef idx="0"/>
+    <cs:effectRef idx="0"/>
+    <cs:fontRef idx="minor">
+      <a:schemeClr val="tx1"/>
+    </cs:fontRef>
+    <cs:spPr>
+      <a:solidFill>
+        <a:schemeClr val="bg1"/>
+      </a:solidFill>
+      <a:ln w="9525" cap="flat" cmpd="sng" algn="ctr">
+        <a:solidFill>
+          <a:schemeClr val="tx1">
+            <a:lumMod val="15000"/>
+            <a:lumOff val="85000"/>
+          </a:schemeClr>
+        </a:solidFill>
+        <a:round/>
+      </a:ln>
+    </cs:spPr>
+    <cs:defRPr sz="1330" kern="1200"/>
+  </cs:chartArea>
+  <cs:dataLabel>
+    <cs:lnRef idx="0"/>
+    <cs:fillRef idx="0"/>
+    <cs:effectRef idx="0"/>
+    <cs:fontRef idx="minor">
+      <a:schemeClr val="tx1">
+        <a:lumMod val="75000"/>
+        <a:lumOff val="25000"/>
+      </a:schemeClr>
+    </cs:fontRef>
+    <cs:defRPr sz="1197" kern="1200"/>
+  </cs:dataLabel>
+  <cs:dataLabelCallout>
+    <cs:lnRef idx="0"/>
+    <cs:fillRef idx="0"/>
+    <cs:effectRef idx="0"/>
+    <cs:fontRef idx="minor">
+      <a:schemeClr val="dk1">
+        <a:lumMod val="65000"/>
+        <a:lumOff val="35000"/>
+      </a:schemeClr>
+    </cs:fontRef>
+    <cs:spPr>
+      <a:solidFill>
+        <a:schemeClr val="lt1"/>
+      </a:solidFill>
+      <a:ln>
+        <a:solidFill>
+          <a:schemeClr val="dk1">
+            <a:lumMod val="25000"/>
+            <a:lumOff val="75000"/>
+          </a:schemeClr>
+        </a:solidFill>
+      </a:ln>
+    </cs:spPr>
+    <cs:defRPr sz="1197" kern="1200"/>
+    <cs:bodyPr rot="0" spcFirstLastPara="1" vertOverflow="clip" horzOverflow="clip" vert="horz" wrap="square" lIns="36576" tIns="18288" rIns="36576" bIns="18288" anchor="ctr" anchorCtr="1">
+      <a:spAutoFit/>
+    </cs:bodyPr>
+  </cs:dataLabelCallout>
+  <cs:dataPoint>
+    <cs:lnRef idx="0"/>
+    <cs:fillRef idx="1">
+      <cs:styleClr val="auto"/>
+    </cs:fillRef>
+    <cs:effectRef idx="0"/>
+    <cs:fontRef idx="minor">
+      <a:schemeClr val="tx1"/>
+    </cs:fontRef>
+    <cs:spPr>
+      <a:solidFill>
+        <a:schemeClr val="phClr">
+          <a:alpha val="75000"/>
+        </a:schemeClr>
+      </a:solidFill>
+    </cs:spPr>
+  </cs:dataPoint>
+  <cs:dataPoint3D>
+    <cs:lnRef idx="0"/>
+    <cs:fillRef idx="1">
+      <cs:styleClr val="auto"/>
+    </cs:fillRef>
+    <cs:effectRef idx="0"/>
+    <cs:fontRef idx="minor">
+      <a:schemeClr val="tx1"/>
+    </cs:fontRef>
+    <cs:spPr>
+      <a:solidFill>
+        <a:schemeClr val="phClr">
+          <a:alpha val="75000"/>
+        </a:schemeClr>
+      </a:solidFill>
+    </cs:spPr>
+  </cs:dataPoint3D>
+  <cs:dataPointLine>
+    <cs:lnRef idx="0">
+      <cs:styleClr val="auto"/>
+    </cs:lnRef>
+    <cs:fillRef idx="1"/>
+    <cs:effectRef idx="0"/>
+    <cs:fontRef idx="minor">
+      <a:schemeClr val="tx1"/>
+    </cs:fontRef>
+    <cs:spPr>
+      <a:ln w="19050" cap="rnd">
+        <a:solidFill>
+          <a:schemeClr val="phClr">
+            <a:alpha val="50000"/>
+          </a:schemeClr>
+        </a:solidFill>
+        <a:round/>
+      </a:ln>
+    </cs:spPr>
+  </cs:dataPointLine>
+  <cs:dataPointMarker>
+    <cs:lnRef idx="0">
+      <cs:styleClr val="auto"/>
+    </cs:lnRef>
+    <cs:fillRef idx="1">
+      <cs:styleClr val="auto"/>
+    </cs:fillRef>
+    <cs:effectRef idx="0"/>
+    <cs:fontRef idx="minor">
+      <a:schemeClr val="tx1"/>
+    </cs:fontRef>
+    <cs:spPr>
       <a:solidFill>
         <a:schemeClr val="phClr"/>
       </a:solidFill>
@@ -12398,6 +13370,208 @@
     </cs:fontRef>
   </cs:wall>
 </cs:chartStyle>
+</file>
+
+<file path=ppt/drawings/drawing1.xml><?xml version="1.0" encoding="utf-8"?>
+<c:userShapes xmlns:c="http://schemas.openxmlformats.org/drawingml/2006/chart">
+  <cdr:relSizeAnchor xmlns:cdr="http://schemas.openxmlformats.org/drawingml/2006/chartDrawing">
+    <cdr:from>
+      <cdr:x>0.42857</cdr:x>
+      <cdr:y>0.1</cdr:y>
+    </cdr:from>
+    <cdr:to>
+      <cdr:x>0.64286</cdr:x>
+      <cdr:y>0.225</cdr:y>
+    </cdr:to>
+    <cdr:sp macro="" textlink="">
+      <cdr:nvSpPr>
+        <cdr:cNvPr id="2" name="Rechteck 1">
+          <a:extLst xmlns:a="http://schemas.openxmlformats.org/drawingml/2006/main">
+            <a:ext uri="{FF2B5EF4-FFF2-40B4-BE49-F238E27FC236}">
+              <a16:creationId xmlns:a16="http://schemas.microsoft.com/office/drawing/2014/main" id="{07BBE01D-23EE-F489-F735-077231DCE024}"/>
+            </a:ext>
+          </a:extLst>
+        </cdr:cNvPr>
+        <cdr:cNvSpPr/>
+      </cdr:nvSpPr>
+      <cdr:spPr>
+        <a:xfrm xmlns:a="http://schemas.openxmlformats.org/drawingml/2006/main">
+          <a:off x="3810000" y="508000"/>
+          <a:ext cx="1905000" cy="635000"/>
+        </a:xfrm>
+        <a:prstGeom xmlns:a="http://schemas.openxmlformats.org/drawingml/2006/main" prst="rect">
+          <a:avLst/>
+        </a:prstGeom>
+      </cdr:spPr>
+      <cdr:style>
+        <a:lnRef xmlns:a="http://schemas.openxmlformats.org/drawingml/2006/main" idx="2">
+          <a:schemeClr val="accent1">
+            <a:shade val="15000"/>
+          </a:schemeClr>
+        </a:lnRef>
+        <a:fillRef xmlns:a="http://schemas.openxmlformats.org/drawingml/2006/main" idx="1">
+          <a:schemeClr val="accent1"/>
+        </a:fillRef>
+        <a:effectRef xmlns:a="http://schemas.openxmlformats.org/drawingml/2006/main" idx="0">
+          <a:schemeClr val="accent1"/>
+        </a:effectRef>
+        <a:fontRef xmlns:a="http://schemas.openxmlformats.org/drawingml/2006/main" idx="minor">
+          <a:schemeClr val="lt1"/>
+        </a:fontRef>
+      </cdr:style>
+      <cdr:txBody>
+        <a:bodyPr xmlns:a="http://schemas.openxmlformats.org/drawingml/2006/main" vertOverflow="clip"/>
+        <a:lstStyle xmlns:a="http://schemas.openxmlformats.org/drawingml/2006/main"/>
+        <a:p xmlns:a="http://schemas.openxmlformats.org/drawingml/2006/main">
+          <a:r>
+            <a:rPr lang="de-DE" kern="1200"/>
+            <a:t>In the chart</a:t>
+          </a:r>
+        </a:p>
+      </cdr:txBody>
+    </cdr:sp>
+  </cdr:relSizeAnchor>
+  <cdr:relSizeAnchor xmlns:cdr="http://schemas.openxmlformats.org/drawingml/2006/chartDrawing">
+    <cdr:from>
+      <cdr:x>0.71429</cdr:x>
+      <cdr:y>0.375</cdr:y>
+    </cdr:from>
+    <cdr:to>
+      <cdr:x>0.82857</cdr:x>
+      <cdr:y>0.575</cdr:y>
+    </cdr:to>
+    <cdr:sp macro="" textlink="">
+      <cdr:nvSpPr>
+        <cdr:cNvPr id="3" name="Ellipse 2">
+          <a:extLst xmlns:a="http://schemas.openxmlformats.org/drawingml/2006/main">
+            <a:ext uri="{FF2B5EF4-FFF2-40B4-BE49-F238E27FC236}">
+              <a16:creationId xmlns:a16="http://schemas.microsoft.com/office/drawing/2014/main" id="{CE2E9742-1789-255F-44F1-5BF901FDE31C}"/>
+            </a:ext>
+          </a:extLst>
+        </cdr:cNvPr>
+        <cdr:cNvSpPr/>
+      </cdr:nvSpPr>
+      <cdr:spPr>
+        <a:xfrm xmlns:a="http://schemas.openxmlformats.org/drawingml/2006/main">
+          <a:off x="6350000" y="1905000"/>
+          <a:ext cx="1016000" cy="1016000"/>
+        </a:xfrm>
+        <a:prstGeom xmlns:a="http://schemas.openxmlformats.org/drawingml/2006/main" prst="ellipse">
+          <a:avLst/>
+        </a:prstGeom>
+      </cdr:spPr>
+      <cdr:style>
+        <a:lnRef xmlns:a="http://schemas.openxmlformats.org/drawingml/2006/main" idx="2">
+          <a:schemeClr val="accent1">
+            <a:shade val="15000"/>
+          </a:schemeClr>
+        </a:lnRef>
+        <a:fillRef xmlns:a="http://schemas.openxmlformats.org/drawingml/2006/main" idx="1">
+          <a:schemeClr val="accent1"/>
+        </a:fillRef>
+        <a:effectRef xmlns:a="http://schemas.openxmlformats.org/drawingml/2006/main" idx="0">
+          <a:schemeClr val="accent1"/>
+        </a:effectRef>
+        <a:fontRef xmlns:a="http://schemas.openxmlformats.org/drawingml/2006/main" idx="minor">
+          <a:schemeClr val="lt1"/>
+        </a:fontRef>
+      </cdr:style>
+      <cdr:txBody>
+        <a:bodyPr xmlns:a="http://schemas.openxmlformats.org/drawingml/2006/main" vertOverflow="clip"/>
+        <a:lstStyle xmlns:a="http://schemas.openxmlformats.org/drawingml/2006/main"/>
+        <a:p xmlns:a="http://schemas.openxmlformats.org/drawingml/2006/main">
+          <a:endParaRPr lang="de-DE" kern="1200"/>
+        </a:p>
+      </cdr:txBody>
+    </cdr:sp>
+  </cdr:relSizeAnchor>
+  <cdr:relSizeAnchor xmlns:cdr="http://schemas.openxmlformats.org/drawingml/2006/chartDrawing">
+    <cdr:from>
+      <cdr:x>0.05714</cdr:x>
+      <cdr:y>0.85</cdr:y>
+    </cdr:from>
+    <cdr:to>
+      <cdr:x>0.34286</cdr:x>
+      <cdr:y>0.925</cdr:y>
+    </cdr:to>
+    <cdr:sp macro="" textlink="">
+      <cdr:nvSpPr>
+        <cdr:cNvPr id="4" name="Textfeld 3">
+          <a:extLst xmlns:a="http://schemas.openxmlformats.org/drawingml/2006/main">
+            <a:ext uri="{FF2B5EF4-FFF2-40B4-BE49-F238E27FC236}">
+              <a16:creationId xmlns:a16="http://schemas.microsoft.com/office/drawing/2014/main" id="{2A76A651-5F81-E9CC-0E5F-8C7DD0D5568D}"/>
+            </a:ext>
+          </a:extLst>
+        </cdr:cNvPr>
+        <cdr:cNvSpPr txBox="1"/>
+      </cdr:nvSpPr>
+      <cdr:spPr>
+        <a:xfrm xmlns:a="http://schemas.openxmlformats.org/drawingml/2006/main">
+          <a:off x="508000" y="4318000"/>
+          <a:ext cx="2540000" cy="381000"/>
+        </a:xfrm>
+        <a:prstGeom xmlns:a="http://schemas.openxmlformats.org/drawingml/2006/main" prst="rect">
+          <a:avLst/>
+        </a:prstGeom>
+      </cdr:spPr>
+      <cdr:txBody>
+        <a:bodyPr xmlns:a="http://schemas.openxmlformats.org/drawingml/2006/main" vertOverflow="clip" vert="horz" rtlCol="0"/>
+        <a:lstStyle xmlns:a="http://schemas.openxmlformats.org/drawingml/2006/main"/>
+        <a:p xmlns:a="http://schemas.openxmlformats.org/drawingml/2006/main">
+          <a:r>
+            <a:rPr lang="de-DE" sz="1100" kern="1200"/>
+            <a:t>A note</a:t>
+          </a:r>
+        </a:p>
+      </cdr:txBody>
+    </cdr:sp>
+  </cdr:relSizeAnchor>
+  <cdr:relSizeAnchor xmlns:cdr="http://schemas.openxmlformats.org/drawingml/2006/chartDrawing">
+    <cdr:from>
+      <cdr:x>0.14286</cdr:x>
+      <cdr:y>0.25</cdr:y>
+    </cdr:from>
+    <cdr:to>
+      <cdr:x>0.35714</cdr:x>
+      <cdr:y>0.5</cdr:y>
+    </cdr:to>
+    <cdr:cxnSp macro="">
+      <cdr:nvCxnSpPr>
+        <cdr:cNvPr id="5" name="Gerader Verbinder 4">
+          <a:extLst xmlns:a="http://schemas.openxmlformats.org/drawingml/2006/main">
+            <a:ext uri="{FF2B5EF4-FFF2-40B4-BE49-F238E27FC236}">
+              <a16:creationId xmlns:a16="http://schemas.microsoft.com/office/drawing/2014/main" id="{B866446F-4609-9DBC-3D83-15F2914BEAFE}"/>
+            </a:ext>
+          </a:extLst>
+        </cdr:cNvPr>
+        <cdr:cNvCxnSpPr/>
+      </cdr:nvCxnSpPr>
+      <cdr:spPr>
+        <a:xfrm xmlns:a="http://schemas.openxmlformats.org/drawingml/2006/main">
+          <a:off x="1270000" y="1270000"/>
+          <a:ext cx="1905000" cy="1270000"/>
+        </a:xfrm>
+        <a:prstGeom xmlns:a="http://schemas.openxmlformats.org/drawingml/2006/main" prst="line">
+          <a:avLst/>
+        </a:prstGeom>
+      </cdr:spPr>
+      <cdr:style>
+        <a:lnRef xmlns:a="http://schemas.openxmlformats.org/drawingml/2006/main" idx="2">
+          <a:schemeClr val="accent1"/>
+        </a:lnRef>
+        <a:fillRef xmlns:a="http://schemas.openxmlformats.org/drawingml/2006/main" idx="0">
+          <a:schemeClr val="accent1"/>
+        </a:fillRef>
+        <a:effectRef xmlns:a="http://schemas.openxmlformats.org/drawingml/2006/main" idx="1">
+          <a:schemeClr val="accent1"/>
+        </a:effectRef>
+        <a:fontRef xmlns:a="http://schemas.openxmlformats.org/drawingml/2006/main" idx="minor">
+          <a:schemeClr val="tx1"/>
+        </a:fontRef>
+      </cdr:style>
+    </cdr:cxnSp>
+  </cdr:relSizeAnchor>
+</c:userShapes>
 </file>
 
 <file path=ppt/slideLayouts/slideLayout1.xml><?xml version="1.0" encoding="utf-8"?>
@@ -12422,7 +13596,7 @@
           <p:cNvPr id="2" name="Titel 1">
             <a:extLst>
               <a:ext uri="{FF2B5EF4-FFF2-40B4-BE49-F238E27FC236}">
-                <a16:creationId xmlns:a16="http://schemas.microsoft.com/office/drawing/2014/main" id="{8DD79572-4484-832F-04F5-AD233E3AD2AD}"/>
+                <a16:creationId xmlns:a16="http://schemas.microsoft.com/office/drawing/2014/main" id="{22B03694-8103-8E45-032F-8E9A90285DBD}"/>
               </a:ext>
             </a:extLst>
           </p:cNvPr>
@@ -12459,7 +13633,7 @@
           <p:cNvPr id="3" name="Untertitel 2">
             <a:extLst>
               <a:ext uri="{FF2B5EF4-FFF2-40B4-BE49-F238E27FC236}">
-                <a16:creationId xmlns:a16="http://schemas.microsoft.com/office/drawing/2014/main" id="{AC831EC8-7CD5-3BB4-8B6E-EAFF871536EA}"/>
+                <a16:creationId xmlns:a16="http://schemas.microsoft.com/office/drawing/2014/main" id="{344D1742-947E-CEBD-E0BF-A156E6E7DCB3}"/>
               </a:ext>
             </a:extLst>
           </p:cNvPr>
@@ -12529,7 +13703,7 @@
           <p:cNvPr id="4" name="Datumsplatzhalter 3">
             <a:extLst>
               <a:ext uri="{FF2B5EF4-FFF2-40B4-BE49-F238E27FC236}">
-                <a16:creationId xmlns:a16="http://schemas.microsoft.com/office/drawing/2014/main" id="{F3349E78-6A1F-6B68-C6D6-0C283CD0DE94}"/>
+                <a16:creationId xmlns:a16="http://schemas.microsoft.com/office/drawing/2014/main" id="{4525E347-2289-7EDC-769D-22638DDAD5A7}"/>
               </a:ext>
             </a:extLst>
           </p:cNvPr>
@@ -12545,7 +13719,7 @@
           <a:bodyPr/>
           <a:lstStyle/>
           <a:p>
-            <a:fld id="{F90D6D3C-F920-4A3C-B787-1F3E94045D68}" type="datetimeFigureOut">
+            <a:fld id="{5995F78A-EF12-451D-A42D-33BA75944712}" type="datetimeFigureOut">
               <a:rPr lang="de-DE" smtClean="0"/>
               <a:t>08.10.2026</a:t>
             </a:fld>
@@ -12558,7 +13732,7 @@
           <p:cNvPr id="5" name="Fußzeilenplatzhalter 4">
             <a:extLst>
               <a:ext uri="{FF2B5EF4-FFF2-40B4-BE49-F238E27FC236}">
-                <a16:creationId xmlns:a16="http://schemas.microsoft.com/office/drawing/2014/main" id="{60107DE2-823A-5C2C-DB4D-0F7212791969}"/>
+                <a16:creationId xmlns:a16="http://schemas.microsoft.com/office/drawing/2014/main" id="{8960F987-B8A1-A623-A6EA-B79338C0A274}"/>
               </a:ext>
             </a:extLst>
           </p:cNvPr>
@@ -12583,7 +13757,7 @@
           <p:cNvPr id="6" name="Foliennummernplatzhalter 5">
             <a:extLst>
               <a:ext uri="{FF2B5EF4-FFF2-40B4-BE49-F238E27FC236}">
-                <a16:creationId xmlns:a16="http://schemas.microsoft.com/office/drawing/2014/main" id="{7FC504D7-35B3-7119-9C33-0092F816C85E}"/>
+                <a16:creationId xmlns:a16="http://schemas.microsoft.com/office/drawing/2014/main" id="{DB7FDFB4-A638-A664-B36C-11C5BFF2EDC5}"/>
               </a:ext>
             </a:extLst>
           </p:cNvPr>
@@ -12599,7 +13773,7 @@
           <a:bodyPr/>
           <a:lstStyle/>
           <a:p>
-            <a:fld id="{AF894DF6-4592-44C9-97EF-4B210170B4D6}" type="slidenum">
+            <a:fld id="{58E1AFF0-AF8B-46F6-A11A-4CAC28041454}" type="slidenum">
               <a:rPr lang="de-DE" smtClean="0"/>
               <a:t>‹Nr.›</a:t>
             </a:fld>
@@ -12610,7 +13784,7 @@
     </p:spTree>
     <p:extLst>
       <p:ext uri="{BB962C8B-B14F-4D97-AF65-F5344CB8AC3E}">
-        <p14:creationId xmlns:p14="http://schemas.microsoft.com/office/powerpoint/2010/main" val="1596480927"/>
+        <p14:creationId xmlns:p14="http://schemas.microsoft.com/office/powerpoint/2010/main" val="3565896866"/>
       </p:ext>
     </p:extLst>
   </p:cSld>
@@ -12642,7 +13816,7 @@
           <p:cNvPr id="2" name="Titel 1">
             <a:extLst>
               <a:ext uri="{FF2B5EF4-FFF2-40B4-BE49-F238E27FC236}">
-                <a16:creationId xmlns:a16="http://schemas.microsoft.com/office/drawing/2014/main" id="{1228ADBC-CD4C-3482-EE93-ACDD7EF0C0D7}"/>
+                <a16:creationId xmlns:a16="http://schemas.microsoft.com/office/drawing/2014/main" id="{DC2A2421-A150-F220-5FC0-A20668B68A58}"/>
               </a:ext>
             </a:extLst>
           </p:cNvPr>
@@ -12670,7 +13844,7 @@
           <p:cNvPr id="3" name="Vertikaler Textplatzhalter 2">
             <a:extLst>
               <a:ext uri="{FF2B5EF4-FFF2-40B4-BE49-F238E27FC236}">
-                <a16:creationId xmlns:a16="http://schemas.microsoft.com/office/drawing/2014/main" id="{BB5532E5-76AF-758F-64E3-1969AB708923}"/>
+                <a16:creationId xmlns:a16="http://schemas.microsoft.com/office/drawing/2014/main" id="{B1A4F93D-3B1D-8F6E-A762-A1FF6084B9E8}"/>
               </a:ext>
             </a:extLst>
           </p:cNvPr>
@@ -12727,7 +13901,7 @@
           <p:cNvPr id="4" name="Datumsplatzhalter 3">
             <a:extLst>
               <a:ext uri="{FF2B5EF4-FFF2-40B4-BE49-F238E27FC236}">
-                <a16:creationId xmlns:a16="http://schemas.microsoft.com/office/drawing/2014/main" id="{8AB97DCD-0279-49F2-74DD-DAB150A175E6}"/>
+                <a16:creationId xmlns:a16="http://schemas.microsoft.com/office/drawing/2014/main" id="{CCA71058-624A-1478-5BCB-86AAA3FFBA9F}"/>
               </a:ext>
             </a:extLst>
           </p:cNvPr>
@@ -12743,7 +13917,7 @@
           <a:bodyPr/>
           <a:lstStyle/>
           <a:p>
-            <a:fld id="{F90D6D3C-F920-4A3C-B787-1F3E94045D68}" type="datetimeFigureOut">
+            <a:fld id="{5995F78A-EF12-451D-A42D-33BA75944712}" type="datetimeFigureOut">
               <a:rPr lang="de-DE" smtClean="0"/>
               <a:t>08.10.2026</a:t>
             </a:fld>
@@ -12756,7 +13930,7 @@
           <p:cNvPr id="5" name="Fußzeilenplatzhalter 4">
             <a:extLst>
               <a:ext uri="{FF2B5EF4-FFF2-40B4-BE49-F238E27FC236}">
-                <a16:creationId xmlns:a16="http://schemas.microsoft.com/office/drawing/2014/main" id="{C2832909-9FBA-D0F5-20FD-494F60856CA0}"/>
+                <a16:creationId xmlns:a16="http://schemas.microsoft.com/office/drawing/2014/main" id="{71B4548A-9B8B-DD02-1CEC-E1799A96EBBD}"/>
               </a:ext>
             </a:extLst>
           </p:cNvPr>
@@ -12781,7 +13955,7 @@
           <p:cNvPr id="6" name="Foliennummernplatzhalter 5">
             <a:extLst>
               <a:ext uri="{FF2B5EF4-FFF2-40B4-BE49-F238E27FC236}">
-                <a16:creationId xmlns:a16="http://schemas.microsoft.com/office/drawing/2014/main" id="{2D17EC71-A382-9BD5-F6B3-A6EC6826F4A8}"/>
+                <a16:creationId xmlns:a16="http://schemas.microsoft.com/office/drawing/2014/main" id="{9E7D20E5-DD1E-2D38-327C-FDB94EE566DB}"/>
               </a:ext>
             </a:extLst>
           </p:cNvPr>
@@ -12797,7 +13971,7 @@
           <a:bodyPr/>
           <a:lstStyle/>
           <a:p>
-            <a:fld id="{AF894DF6-4592-44C9-97EF-4B210170B4D6}" type="slidenum">
+            <a:fld id="{58E1AFF0-AF8B-46F6-A11A-4CAC28041454}" type="slidenum">
               <a:rPr lang="de-DE" smtClean="0"/>
               <a:t>‹Nr.›</a:t>
             </a:fld>
@@ -12808,7 +13982,7 @@
     </p:spTree>
     <p:extLst>
       <p:ext uri="{BB962C8B-B14F-4D97-AF65-F5344CB8AC3E}">
-        <p14:creationId xmlns:p14="http://schemas.microsoft.com/office/powerpoint/2010/main" val="454477510"/>
+        <p14:creationId xmlns:p14="http://schemas.microsoft.com/office/powerpoint/2010/main" val="48265340"/>
       </p:ext>
     </p:extLst>
   </p:cSld>
@@ -12840,7 +14014,7 @@
           <p:cNvPr id="2" name="Vertikaler Titel 1">
             <a:extLst>
               <a:ext uri="{FF2B5EF4-FFF2-40B4-BE49-F238E27FC236}">
-                <a16:creationId xmlns:a16="http://schemas.microsoft.com/office/drawing/2014/main" id="{DC76CF15-D22C-B1F4-EBE4-8E74DBDD5D36}"/>
+                <a16:creationId xmlns:a16="http://schemas.microsoft.com/office/drawing/2014/main" id="{1947B512-5255-04AC-4A20-E0013E4749E2}"/>
               </a:ext>
             </a:extLst>
           </p:cNvPr>
@@ -12873,7 +14047,7 @@
           <p:cNvPr id="3" name="Vertikaler Textplatzhalter 2">
             <a:extLst>
               <a:ext uri="{FF2B5EF4-FFF2-40B4-BE49-F238E27FC236}">
-                <a16:creationId xmlns:a16="http://schemas.microsoft.com/office/drawing/2014/main" id="{2745CF96-6DBB-3633-77AB-1E5F5D00942A}"/>
+                <a16:creationId xmlns:a16="http://schemas.microsoft.com/office/drawing/2014/main" id="{6C37F2D0-C249-A8AF-9ADE-0497A84107C1}"/>
               </a:ext>
             </a:extLst>
           </p:cNvPr>
@@ -12935,7 +14109,7 @@
           <p:cNvPr id="4" name="Datumsplatzhalter 3">
             <a:extLst>
               <a:ext uri="{FF2B5EF4-FFF2-40B4-BE49-F238E27FC236}">
-                <a16:creationId xmlns:a16="http://schemas.microsoft.com/office/drawing/2014/main" id="{AE96C7CA-E2CC-B7C8-06C0-6440430B5810}"/>
+                <a16:creationId xmlns:a16="http://schemas.microsoft.com/office/drawing/2014/main" id="{24F1C6D7-1D39-2C63-53A2-01AC6E12F0CE}"/>
               </a:ext>
             </a:extLst>
           </p:cNvPr>
@@ -12951,7 +14125,7 @@
           <a:bodyPr/>
           <a:lstStyle/>
           <a:p>
-            <a:fld id="{F90D6D3C-F920-4A3C-B787-1F3E94045D68}" type="datetimeFigureOut">
+            <a:fld id="{5995F78A-EF12-451D-A42D-33BA75944712}" type="datetimeFigureOut">
               <a:rPr lang="de-DE" smtClean="0"/>
               <a:t>08.10.2026</a:t>
             </a:fld>
@@ -12964,7 +14138,7 @@
           <p:cNvPr id="5" name="Fußzeilenplatzhalter 4">
             <a:extLst>
               <a:ext uri="{FF2B5EF4-FFF2-40B4-BE49-F238E27FC236}">
-                <a16:creationId xmlns:a16="http://schemas.microsoft.com/office/drawing/2014/main" id="{DC6794F9-1DE7-06A4-91E9-B65DA4E1E116}"/>
+                <a16:creationId xmlns:a16="http://schemas.microsoft.com/office/drawing/2014/main" id="{46490011-4F21-8612-C514-08352ED62B4A}"/>
               </a:ext>
             </a:extLst>
           </p:cNvPr>
@@ -12989,7 +14163,7 @@
           <p:cNvPr id="6" name="Foliennummernplatzhalter 5">
             <a:extLst>
               <a:ext uri="{FF2B5EF4-FFF2-40B4-BE49-F238E27FC236}">
-                <a16:creationId xmlns:a16="http://schemas.microsoft.com/office/drawing/2014/main" id="{AB78C0D1-1677-8664-49B9-8E6E5550EC4E}"/>
+                <a16:creationId xmlns:a16="http://schemas.microsoft.com/office/drawing/2014/main" id="{F947D86C-AFAF-EB09-38FA-4FDCBE4B8FF5}"/>
               </a:ext>
             </a:extLst>
           </p:cNvPr>
@@ -13005,7 +14179,7 @@
           <a:bodyPr/>
           <a:lstStyle/>
           <a:p>
-            <a:fld id="{AF894DF6-4592-44C9-97EF-4B210170B4D6}" type="slidenum">
+            <a:fld id="{58E1AFF0-AF8B-46F6-A11A-4CAC28041454}" type="slidenum">
               <a:rPr lang="de-DE" smtClean="0"/>
               <a:t>‹Nr.›</a:t>
             </a:fld>
@@ -13016,7 +14190,7 @@
     </p:spTree>
     <p:extLst>
       <p:ext uri="{BB962C8B-B14F-4D97-AF65-F5344CB8AC3E}">
-        <p14:creationId xmlns:p14="http://schemas.microsoft.com/office/powerpoint/2010/main" val="4201924038"/>
+        <p14:creationId xmlns:p14="http://schemas.microsoft.com/office/powerpoint/2010/main" val="2219927665"/>
       </p:ext>
     </p:extLst>
   </p:cSld>
@@ -13048,7 +14222,7 @@
           <p:cNvPr id="2" name="Titel 1">
             <a:extLst>
               <a:ext uri="{FF2B5EF4-FFF2-40B4-BE49-F238E27FC236}">
-                <a16:creationId xmlns:a16="http://schemas.microsoft.com/office/drawing/2014/main" id="{5A6FB668-967E-3A14-B917-7820B881644A}"/>
+                <a16:creationId xmlns:a16="http://schemas.microsoft.com/office/drawing/2014/main" id="{08C8FDA0-A029-0209-DBAB-6D99F3EF890B}"/>
               </a:ext>
             </a:extLst>
           </p:cNvPr>
@@ -13076,7 +14250,7 @@
           <p:cNvPr id="3" name="Inhaltsplatzhalter 2">
             <a:extLst>
               <a:ext uri="{FF2B5EF4-FFF2-40B4-BE49-F238E27FC236}">
-                <a16:creationId xmlns:a16="http://schemas.microsoft.com/office/drawing/2014/main" id="{0558EA57-1460-E682-DE11-0BC5095321A5}"/>
+                <a16:creationId xmlns:a16="http://schemas.microsoft.com/office/drawing/2014/main" id="{7939A4A1-4C96-EE8C-F086-05BD6A147409}"/>
               </a:ext>
             </a:extLst>
           </p:cNvPr>
@@ -13133,7 +14307,7 @@
           <p:cNvPr id="4" name="Datumsplatzhalter 3">
             <a:extLst>
               <a:ext uri="{FF2B5EF4-FFF2-40B4-BE49-F238E27FC236}">
-                <a16:creationId xmlns:a16="http://schemas.microsoft.com/office/drawing/2014/main" id="{90A00708-FCF2-255D-5D93-4CAB191D2FC9}"/>
+                <a16:creationId xmlns:a16="http://schemas.microsoft.com/office/drawing/2014/main" id="{8D66A602-8A86-54D2-E019-06ECDB8C0CE2}"/>
               </a:ext>
             </a:extLst>
           </p:cNvPr>
@@ -13149,7 +14323,7 @@
           <a:bodyPr/>
           <a:lstStyle/>
           <a:p>
-            <a:fld id="{F90D6D3C-F920-4A3C-B787-1F3E94045D68}" type="datetimeFigureOut">
+            <a:fld id="{5995F78A-EF12-451D-A42D-33BA75944712}" type="datetimeFigureOut">
               <a:rPr lang="de-DE" smtClean="0"/>
               <a:t>08.10.2026</a:t>
             </a:fld>
@@ -13162,7 +14336,7 @@
           <p:cNvPr id="5" name="Fußzeilenplatzhalter 4">
             <a:extLst>
               <a:ext uri="{FF2B5EF4-FFF2-40B4-BE49-F238E27FC236}">
-                <a16:creationId xmlns:a16="http://schemas.microsoft.com/office/drawing/2014/main" id="{94172218-8C27-9EEC-DE5B-9F7006C05F7F}"/>
+                <a16:creationId xmlns:a16="http://schemas.microsoft.com/office/drawing/2014/main" id="{B9E89839-D80E-9953-F1A8-99EDBEB49D40}"/>
               </a:ext>
             </a:extLst>
           </p:cNvPr>
@@ -13187,7 +14361,7 @@
           <p:cNvPr id="6" name="Foliennummernplatzhalter 5">
             <a:extLst>
               <a:ext uri="{FF2B5EF4-FFF2-40B4-BE49-F238E27FC236}">
-                <a16:creationId xmlns:a16="http://schemas.microsoft.com/office/drawing/2014/main" id="{45F954FF-A756-F27B-7396-701380A4D5AA}"/>
+                <a16:creationId xmlns:a16="http://schemas.microsoft.com/office/drawing/2014/main" id="{133351C6-DED6-413C-3D91-4D0D69C80D32}"/>
               </a:ext>
             </a:extLst>
           </p:cNvPr>
@@ -13203,7 +14377,7 @@
           <a:bodyPr/>
           <a:lstStyle/>
           <a:p>
-            <a:fld id="{AF894DF6-4592-44C9-97EF-4B210170B4D6}" type="slidenum">
+            <a:fld id="{58E1AFF0-AF8B-46F6-A11A-4CAC28041454}" type="slidenum">
               <a:rPr lang="de-DE" smtClean="0"/>
               <a:t>‹Nr.›</a:t>
             </a:fld>
@@ -13214,7 +14388,7 @@
     </p:spTree>
     <p:extLst>
       <p:ext uri="{BB962C8B-B14F-4D97-AF65-F5344CB8AC3E}">
-        <p14:creationId xmlns:p14="http://schemas.microsoft.com/office/powerpoint/2010/main" val="512909722"/>
+        <p14:creationId xmlns:p14="http://schemas.microsoft.com/office/powerpoint/2010/main" val="2955645901"/>
       </p:ext>
     </p:extLst>
   </p:cSld>
@@ -13246,7 +14420,7 @@
           <p:cNvPr id="2" name="Titel 1">
             <a:extLst>
               <a:ext uri="{FF2B5EF4-FFF2-40B4-BE49-F238E27FC236}">
-                <a16:creationId xmlns:a16="http://schemas.microsoft.com/office/drawing/2014/main" id="{6ACB07E5-48E5-B152-932C-9CC5FE6282F2}"/>
+                <a16:creationId xmlns:a16="http://schemas.microsoft.com/office/drawing/2014/main" id="{01B910DE-89B2-C815-54C2-FC518C853609}"/>
               </a:ext>
             </a:extLst>
           </p:cNvPr>
@@ -13283,7 +14457,7 @@
           <p:cNvPr id="3" name="Textplatzhalter 2">
             <a:extLst>
               <a:ext uri="{FF2B5EF4-FFF2-40B4-BE49-F238E27FC236}">
-                <a16:creationId xmlns:a16="http://schemas.microsoft.com/office/drawing/2014/main" id="{D3AA94BA-A8C7-49C6-A9FE-FB5B26618FE3}"/>
+                <a16:creationId xmlns:a16="http://schemas.microsoft.com/office/drawing/2014/main" id="{8AC26B97-3460-3663-ECE9-FF2EC60B850C}"/>
               </a:ext>
             </a:extLst>
           </p:cNvPr>
@@ -13408,7 +14582,7 @@
           <p:cNvPr id="4" name="Datumsplatzhalter 3">
             <a:extLst>
               <a:ext uri="{FF2B5EF4-FFF2-40B4-BE49-F238E27FC236}">
-                <a16:creationId xmlns:a16="http://schemas.microsoft.com/office/drawing/2014/main" id="{1FF18CC6-006D-916C-2C1E-25EB81B6A848}"/>
+                <a16:creationId xmlns:a16="http://schemas.microsoft.com/office/drawing/2014/main" id="{D5A698D1-3761-F75A-EBA8-7884992600BD}"/>
               </a:ext>
             </a:extLst>
           </p:cNvPr>
@@ -13424,7 +14598,7 @@
           <a:bodyPr/>
           <a:lstStyle/>
           <a:p>
-            <a:fld id="{F90D6D3C-F920-4A3C-B787-1F3E94045D68}" type="datetimeFigureOut">
+            <a:fld id="{5995F78A-EF12-451D-A42D-33BA75944712}" type="datetimeFigureOut">
               <a:rPr lang="de-DE" smtClean="0"/>
               <a:t>08.10.2026</a:t>
             </a:fld>
@@ -13437,7 +14611,7 @@
           <p:cNvPr id="5" name="Fußzeilenplatzhalter 4">
             <a:extLst>
               <a:ext uri="{FF2B5EF4-FFF2-40B4-BE49-F238E27FC236}">
-                <a16:creationId xmlns:a16="http://schemas.microsoft.com/office/drawing/2014/main" id="{43C2C0E8-1227-4E6A-200B-DCF258FBEE08}"/>
+                <a16:creationId xmlns:a16="http://schemas.microsoft.com/office/drawing/2014/main" id="{B4BF9BDA-2F59-5047-6529-320A36AE0DB2}"/>
               </a:ext>
             </a:extLst>
           </p:cNvPr>
@@ -13462,7 +14636,7 @@
           <p:cNvPr id="6" name="Foliennummernplatzhalter 5">
             <a:extLst>
               <a:ext uri="{FF2B5EF4-FFF2-40B4-BE49-F238E27FC236}">
-                <a16:creationId xmlns:a16="http://schemas.microsoft.com/office/drawing/2014/main" id="{B2E11DEC-B207-8061-DBCF-5ADC698271ED}"/>
+                <a16:creationId xmlns:a16="http://schemas.microsoft.com/office/drawing/2014/main" id="{B9FA77FB-B9E7-8110-1A31-C35284B309C8}"/>
               </a:ext>
             </a:extLst>
           </p:cNvPr>
@@ -13478,7 +14652,7 @@
           <a:bodyPr/>
           <a:lstStyle/>
           <a:p>
-            <a:fld id="{AF894DF6-4592-44C9-97EF-4B210170B4D6}" type="slidenum">
+            <a:fld id="{58E1AFF0-AF8B-46F6-A11A-4CAC28041454}" type="slidenum">
               <a:rPr lang="de-DE" smtClean="0"/>
               <a:t>‹Nr.›</a:t>
             </a:fld>
@@ -13489,7 +14663,7 @@
     </p:spTree>
     <p:extLst>
       <p:ext uri="{BB962C8B-B14F-4D97-AF65-F5344CB8AC3E}">
-        <p14:creationId xmlns:p14="http://schemas.microsoft.com/office/powerpoint/2010/main" val="825397844"/>
+        <p14:creationId xmlns:p14="http://schemas.microsoft.com/office/powerpoint/2010/main" val="1374354163"/>
       </p:ext>
     </p:extLst>
   </p:cSld>
@@ -13521,7 +14695,7 @@
           <p:cNvPr id="2" name="Titel 1">
             <a:extLst>
               <a:ext uri="{FF2B5EF4-FFF2-40B4-BE49-F238E27FC236}">
-                <a16:creationId xmlns:a16="http://schemas.microsoft.com/office/drawing/2014/main" id="{470A075D-F507-93BC-98AA-F419FC022C31}"/>
+                <a16:creationId xmlns:a16="http://schemas.microsoft.com/office/drawing/2014/main" id="{33FC1209-7AEB-C17E-FFB9-2F2B83061ED4}"/>
               </a:ext>
             </a:extLst>
           </p:cNvPr>
@@ -13549,7 +14723,7 @@
           <p:cNvPr id="3" name="Inhaltsplatzhalter 2">
             <a:extLst>
               <a:ext uri="{FF2B5EF4-FFF2-40B4-BE49-F238E27FC236}">
-                <a16:creationId xmlns:a16="http://schemas.microsoft.com/office/drawing/2014/main" id="{28B8EECF-3ABB-84B8-8746-F99F4782222F}"/>
+                <a16:creationId xmlns:a16="http://schemas.microsoft.com/office/drawing/2014/main" id="{ECB6A5C5-600F-382D-8E91-DFDD31EE17BE}"/>
               </a:ext>
             </a:extLst>
           </p:cNvPr>
@@ -13611,7 +14785,7 @@
           <p:cNvPr id="4" name="Inhaltsplatzhalter 3">
             <a:extLst>
               <a:ext uri="{FF2B5EF4-FFF2-40B4-BE49-F238E27FC236}">
-                <a16:creationId xmlns:a16="http://schemas.microsoft.com/office/drawing/2014/main" id="{A0570072-4B08-908A-24C1-D9C57F881627}"/>
+                <a16:creationId xmlns:a16="http://schemas.microsoft.com/office/drawing/2014/main" id="{A5F4B879-9FA0-F4A4-223F-AED04193B6F3}"/>
               </a:ext>
             </a:extLst>
           </p:cNvPr>
@@ -13673,7 +14847,7 @@
           <p:cNvPr id="5" name="Datumsplatzhalter 4">
             <a:extLst>
               <a:ext uri="{FF2B5EF4-FFF2-40B4-BE49-F238E27FC236}">
-                <a16:creationId xmlns:a16="http://schemas.microsoft.com/office/drawing/2014/main" id="{DB35ECBB-5631-7A13-04DF-01D9B967CDEC}"/>
+                <a16:creationId xmlns:a16="http://schemas.microsoft.com/office/drawing/2014/main" id="{E46DDF08-B82D-75EF-2F8A-7A1C0E057C51}"/>
               </a:ext>
             </a:extLst>
           </p:cNvPr>
@@ -13689,7 +14863,7 @@
           <a:bodyPr/>
           <a:lstStyle/>
           <a:p>
-            <a:fld id="{F90D6D3C-F920-4A3C-B787-1F3E94045D68}" type="datetimeFigureOut">
+            <a:fld id="{5995F78A-EF12-451D-A42D-33BA75944712}" type="datetimeFigureOut">
               <a:rPr lang="de-DE" smtClean="0"/>
               <a:t>08.10.2026</a:t>
             </a:fld>
@@ -13702,7 +14876,7 @@
           <p:cNvPr id="6" name="Fußzeilenplatzhalter 5">
             <a:extLst>
               <a:ext uri="{FF2B5EF4-FFF2-40B4-BE49-F238E27FC236}">
-                <a16:creationId xmlns:a16="http://schemas.microsoft.com/office/drawing/2014/main" id="{7E9C2659-3495-026A-DE9E-F5D8E0E0BC7B}"/>
+                <a16:creationId xmlns:a16="http://schemas.microsoft.com/office/drawing/2014/main" id="{4449FB86-72A2-6022-5008-781BF62FE73C}"/>
               </a:ext>
             </a:extLst>
           </p:cNvPr>
@@ -13727,7 +14901,7 @@
           <p:cNvPr id="7" name="Foliennummernplatzhalter 6">
             <a:extLst>
               <a:ext uri="{FF2B5EF4-FFF2-40B4-BE49-F238E27FC236}">
-                <a16:creationId xmlns:a16="http://schemas.microsoft.com/office/drawing/2014/main" id="{5311C13A-2CFA-DC7F-0F08-D10EFBBE5E52}"/>
+                <a16:creationId xmlns:a16="http://schemas.microsoft.com/office/drawing/2014/main" id="{CD60D15F-94CF-8980-AF4C-BCF34801C580}"/>
               </a:ext>
             </a:extLst>
           </p:cNvPr>
@@ -13743,7 +14917,7 @@
           <a:bodyPr/>
           <a:lstStyle/>
           <a:p>
-            <a:fld id="{AF894DF6-4592-44C9-97EF-4B210170B4D6}" type="slidenum">
+            <a:fld id="{58E1AFF0-AF8B-46F6-A11A-4CAC28041454}" type="slidenum">
               <a:rPr lang="de-DE" smtClean="0"/>
               <a:t>‹Nr.›</a:t>
             </a:fld>
@@ -13754,7 +14928,7 @@
     </p:spTree>
     <p:extLst>
       <p:ext uri="{BB962C8B-B14F-4D97-AF65-F5344CB8AC3E}">
-        <p14:creationId xmlns:p14="http://schemas.microsoft.com/office/powerpoint/2010/main" val="3447134033"/>
+        <p14:creationId xmlns:p14="http://schemas.microsoft.com/office/powerpoint/2010/main" val="237980961"/>
       </p:ext>
     </p:extLst>
   </p:cSld>
@@ -13786,7 +14960,7 @@
           <p:cNvPr id="2" name="Titel 1">
             <a:extLst>
               <a:ext uri="{FF2B5EF4-FFF2-40B4-BE49-F238E27FC236}">
-                <a16:creationId xmlns:a16="http://schemas.microsoft.com/office/drawing/2014/main" id="{E2171400-2E77-08D4-AEEE-6AD64E44F8E1}"/>
+                <a16:creationId xmlns:a16="http://schemas.microsoft.com/office/drawing/2014/main" id="{41F769C4-6807-0752-D4A8-C6F4F57752CC}"/>
               </a:ext>
             </a:extLst>
           </p:cNvPr>
@@ -13819,7 +14993,7 @@
           <p:cNvPr id="3" name="Textplatzhalter 2">
             <a:extLst>
               <a:ext uri="{FF2B5EF4-FFF2-40B4-BE49-F238E27FC236}">
-                <a16:creationId xmlns:a16="http://schemas.microsoft.com/office/drawing/2014/main" id="{46F33B3C-D587-0DEF-9F8A-610E947A0D4E}"/>
+                <a16:creationId xmlns:a16="http://schemas.microsoft.com/office/drawing/2014/main" id="{F1EE71A1-8A00-B50E-A858-896D09044B6A}"/>
               </a:ext>
             </a:extLst>
           </p:cNvPr>
@@ -13890,7 +15064,7 @@
           <p:cNvPr id="4" name="Inhaltsplatzhalter 3">
             <a:extLst>
               <a:ext uri="{FF2B5EF4-FFF2-40B4-BE49-F238E27FC236}">
-                <a16:creationId xmlns:a16="http://schemas.microsoft.com/office/drawing/2014/main" id="{91491D96-A7C3-DEBF-D97C-DC73074291DF}"/>
+                <a16:creationId xmlns:a16="http://schemas.microsoft.com/office/drawing/2014/main" id="{DB2384F7-E55A-0283-2AF7-93CD11309C3E}"/>
               </a:ext>
             </a:extLst>
           </p:cNvPr>
@@ -13952,7 +15126,7 @@
           <p:cNvPr id="5" name="Textplatzhalter 4">
             <a:extLst>
               <a:ext uri="{FF2B5EF4-FFF2-40B4-BE49-F238E27FC236}">
-                <a16:creationId xmlns:a16="http://schemas.microsoft.com/office/drawing/2014/main" id="{5BC47E78-80DC-6E40-02C2-02139C552F97}"/>
+                <a16:creationId xmlns:a16="http://schemas.microsoft.com/office/drawing/2014/main" id="{ED7CEC6A-BF34-27C5-D631-5BE482EF3E49}"/>
               </a:ext>
             </a:extLst>
           </p:cNvPr>
@@ -14023,7 +15197,7 @@
           <p:cNvPr id="6" name="Inhaltsplatzhalter 5">
             <a:extLst>
               <a:ext uri="{FF2B5EF4-FFF2-40B4-BE49-F238E27FC236}">
-                <a16:creationId xmlns:a16="http://schemas.microsoft.com/office/drawing/2014/main" id="{C0BED3C5-8DF8-910F-0D97-0C2658042096}"/>
+                <a16:creationId xmlns:a16="http://schemas.microsoft.com/office/drawing/2014/main" id="{062B6EDC-EFC1-27D9-E1EA-638700820594}"/>
               </a:ext>
             </a:extLst>
           </p:cNvPr>
@@ -14085,7 +15259,7 @@
           <p:cNvPr id="7" name="Datumsplatzhalter 6">
             <a:extLst>
               <a:ext uri="{FF2B5EF4-FFF2-40B4-BE49-F238E27FC236}">
-                <a16:creationId xmlns:a16="http://schemas.microsoft.com/office/drawing/2014/main" id="{1BC6CEB7-F1BF-B245-D331-6EDCFCD11019}"/>
+                <a16:creationId xmlns:a16="http://schemas.microsoft.com/office/drawing/2014/main" id="{92174498-953E-25AE-2F26-5DEB00900159}"/>
               </a:ext>
             </a:extLst>
           </p:cNvPr>
@@ -14101,7 +15275,7 @@
           <a:bodyPr/>
           <a:lstStyle/>
           <a:p>
-            <a:fld id="{F90D6D3C-F920-4A3C-B787-1F3E94045D68}" type="datetimeFigureOut">
+            <a:fld id="{5995F78A-EF12-451D-A42D-33BA75944712}" type="datetimeFigureOut">
               <a:rPr lang="de-DE" smtClean="0"/>
               <a:t>08.10.2026</a:t>
             </a:fld>
@@ -14114,7 +15288,7 @@
           <p:cNvPr id="8" name="Fußzeilenplatzhalter 7">
             <a:extLst>
               <a:ext uri="{FF2B5EF4-FFF2-40B4-BE49-F238E27FC236}">
-                <a16:creationId xmlns:a16="http://schemas.microsoft.com/office/drawing/2014/main" id="{C737969A-714E-3412-8B7C-6FAEAFBB6F6C}"/>
+                <a16:creationId xmlns:a16="http://schemas.microsoft.com/office/drawing/2014/main" id="{04844609-D105-BD56-611B-1DA7BAD26FE6}"/>
               </a:ext>
             </a:extLst>
           </p:cNvPr>
@@ -14139,7 +15313,7 @@
           <p:cNvPr id="9" name="Foliennummernplatzhalter 8">
             <a:extLst>
               <a:ext uri="{FF2B5EF4-FFF2-40B4-BE49-F238E27FC236}">
-                <a16:creationId xmlns:a16="http://schemas.microsoft.com/office/drawing/2014/main" id="{A782E7F6-6DD5-9BB8-6F22-CF9EFF8CBCBB}"/>
+                <a16:creationId xmlns:a16="http://schemas.microsoft.com/office/drawing/2014/main" id="{9EEB5A39-D4F0-1446-5EB1-7093473D2258}"/>
               </a:ext>
             </a:extLst>
           </p:cNvPr>
@@ -14155,7 +15329,7 @@
           <a:bodyPr/>
           <a:lstStyle/>
           <a:p>
-            <a:fld id="{AF894DF6-4592-44C9-97EF-4B210170B4D6}" type="slidenum">
+            <a:fld id="{58E1AFF0-AF8B-46F6-A11A-4CAC28041454}" type="slidenum">
               <a:rPr lang="de-DE" smtClean="0"/>
               <a:t>‹Nr.›</a:t>
             </a:fld>
@@ -14166,7 +15340,7 @@
     </p:spTree>
     <p:extLst>
       <p:ext uri="{BB962C8B-B14F-4D97-AF65-F5344CB8AC3E}">
-        <p14:creationId xmlns:p14="http://schemas.microsoft.com/office/powerpoint/2010/main" val="880888080"/>
+        <p14:creationId xmlns:p14="http://schemas.microsoft.com/office/powerpoint/2010/main" val="3524326099"/>
       </p:ext>
     </p:extLst>
   </p:cSld>
@@ -14198,7 +15372,7 @@
           <p:cNvPr id="2" name="Titel 1">
             <a:extLst>
               <a:ext uri="{FF2B5EF4-FFF2-40B4-BE49-F238E27FC236}">
-                <a16:creationId xmlns:a16="http://schemas.microsoft.com/office/drawing/2014/main" id="{FB8CFD13-F89A-FB8B-A747-A5E60BFCEBBD}"/>
+                <a16:creationId xmlns:a16="http://schemas.microsoft.com/office/drawing/2014/main" id="{ACC02EA1-493C-CDD5-BC59-1538D31BBF3A}"/>
               </a:ext>
             </a:extLst>
           </p:cNvPr>
@@ -14226,7 +15400,7 @@
           <p:cNvPr id="3" name="Datumsplatzhalter 2">
             <a:extLst>
               <a:ext uri="{FF2B5EF4-FFF2-40B4-BE49-F238E27FC236}">
-                <a16:creationId xmlns:a16="http://schemas.microsoft.com/office/drawing/2014/main" id="{6EB6F3AE-E248-0EFC-0558-DD2652F3DE60}"/>
+                <a16:creationId xmlns:a16="http://schemas.microsoft.com/office/drawing/2014/main" id="{C484CA2B-6F96-60FA-8C68-8F041AADCDA5}"/>
               </a:ext>
             </a:extLst>
           </p:cNvPr>
@@ -14242,7 +15416,7 @@
           <a:bodyPr/>
           <a:lstStyle/>
           <a:p>
-            <a:fld id="{F90D6D3C-F920-4A3C-B787-1F3E94045D68}" type="datetimeFigureOut">
+            <a:fld id="{5995F78A-EF12-451D-A42D-33BA75944712}" type="datetimeFigureOut">
               <a:rPr lang="de-DE" smtClean="0"/>
               <a:t>08.10.2026</a:t>
             </a:fld>
@@ -14255,7 +15429,7 @@
           <p:cNvPr id="4" name="Fußzeilenplatzhalter 3">
             <a:extLst>
               <a:ext uri="{FF2B5EF4-FFF2-40B4-BE49-F238E27FC236}">
-                <a16:creationId xmlns:a16="http://schemas.microsoft.com/office/drawing/2014/main" id="{7998BEC5-7DF0-9035-1A82-DC710952A551}"/>
+                <a16:creationId xmlns:a16="http://schemas.microsoft.com/office/drawing/2014/main" id="{4FC5BED7-807A-2E24-2F88-D2EAAF55BD0C}"/>
               </a:ext>
             </a:extLst>
           </p:cNvPr>
@@ -14280,7 +15454,7 @@
           <p:cNvPr id="5" name="Foliennummernplatzhalter 4">
             <a:extLst>
               <a:ext uri="{FF2B5EF4-FFF2-40B4-BE49-F238E27FC236}">
-                <a16:creationId xmlns:a16="http://schemas.microsoft.com/office/drawing/2014/main" id="{DE391EC4-9317-7390-70DF-495E4A3BFD5E}"/>
+                <a16:creationId xmlns:a16="http://schemas.microsoft.com/office/drawing/2014/main" id="{FECEF7E0-D442-544E-DD12-6ABD29C2818E}"/>
               </a:ext>
             </a:extLst>
           </p:cNvPr>
@@ -14296,7 +15470,7 @@
           <a:bodyPr/>
           <a:lstStyle/>
           <a:p>
-            <a:fld id="{AF894DF6-4592-44C9-97EF-4B210170B4D6}" type="slidenum">
+            <a:fld id="{58E1AFF0-AF8B-46F6-A11A-4CAC28041454}" type="slidenum">
               <a:rPr lang="de-DE" smtClean="0"/>
               <a:t>‹Nr.›</a:t>
             </a:fld>
@@ -14307,7 +15481,7 @@
     </p:spTree>
     <p:extLst>
       <p:ext uri="{BB962C8B-B14F-4D97-AF65-F5344CB8AC3E}">
-        <p14:creationId xmlns:p14="http://schemas.microsoft.com/office/powerpoint/2010/main" val="3307788712"/>
+        <p14:creationId xmlns:p14="http://schemas.microsoft.com/office/powerpoint/2010/main" val="439682038"/>
       </p:ext>
     </p:extLst>
   </p:cSld>
@@ -14339,7 +15513,7 @@
           <p:cNvPr id="2" name="Datumsplatzhalter 1">
             <a:extLst>
               <a:ext uri="{FF2B5EF4-FFF2-40B4-BE49-F238E27FC236}">
-                <a16:creationId xmlns:a16="http://schemas.microsoft.com/office/drawing/2014/main" id="{11291723-3B65-ADB5-D586-DF42AA81FEF0}"/>
+                <a16:creationId xmlns:a16="http://schemas.microsoft.com/office/drawing/2014/main" id="{D5A66C06-CD56-D2E5-9B27-63E5633AF08E}"/>
               </a:ext>
             </a:extLst>
           </p:cNvPr>
@@ -14355,7 +15529,7 @@
           <a:bodyPr/>
           <a:lstStyle/>
           <a:p>
-            <a:fld id="{F90D6D3C-F920-4A3C-B787-1F3E94045D68}" type="datetimeFigureOut">
+            <a:fld id="{5995F78A-EF12-451D-A42D-33BA75944712}" type="datetimeFigureOut">
               <a:rPr lang="de-DE" smtClean="0"/>
               <a:t>08.10.2026</a:t>
             </a:fld>
@@ -14368,7 +15542,7 @@
           <p:cNvPr id="3" name="Fußzeilenplatzhalter 2">
             <a:extLst>
               <a:ext uri="{FF2B5EF4-FFF2-40B4-BE49-F238E27FC236}">
-                <a16:creationId xmlns:a16="http://schemas.microsoft.com/office/drawing/2014/main" id="{2D1C784B-4E64-4077-7E59-FAC8CADDA731}"/>
+                <a16:creationId xmlns:a16="http://schemas.microsoft.com/office/drawing/2014/main" id="{749C0A78-DE5A-A283-B756-5390EC94AFDF}"/>
               </a:ext>
             </a:extLst>
           </p:cNvPr>
@@ -14393,7 +15567,7 @@
           <p:cNvPr id="4" name="Foliennummernplatzhalter 3">
             <a:extLst>
               <a:ext uri="{FF2B5EF4-FFF2-40B4-BE49-F238E27FC236}">
-                <a16:creationId xmlns:a16="http://schemas.microsoft.com/office/drawing/2014/main" id="{C7443F46-3915-143F-7276-CDD5FB24072D}"/>
+                <a16:creationId xmlns:a16="http://schemas.microsoft.com/office/drawing/2014/main" id="{CC0E8659-4630-40BA-F766-3EE5A77ED882}"/>
               </a:ext>
             </a:extLst>
           </p:cNvPr>
@@ -14409,7 +15583,7 @@
           <a:bodyPr/>
           <a:lstStyle/>
           <a:p>
-            <a:fld id="{AF894DF6-4592-44C9-97EF-4B210170B4D6}" type="slidenum">
+            <a:fld id="{58E1AFF0-AF8B-46F6-A11A-4CAC28041454}" type="slidenum">
               <a:rPr lang="de-DE" smtClean="0"/>
               <a:t>‹Nr.›</a:t>
             </a:fld>
@@ -14420,7 +15594,7 @@
     </p:spTree>
     <p:extLst>
       <p:ext uri="{BB962C8B-B14F-4D97-AF65-F5344CB8AC3E}">
-        <p14:creationId xmlns:p14="http://schemas.microsoft.com/office/powerpoint/2010/main" val="2530557810"/>
+        <p14:creationId xmlns:p14="http://schemas.microsoft.com/office/powerpoint/2010/main" val="658562676"/>
       </p:ext>
     </p:extLst>
   </p:cSld>
@@ -14452,7 +15626,7 @@
           <p:cNvPr id="2" name="Titel 1">
             <a:extLst>
               <a:ext uri="{FF2B5EF4-FFF2-40B4-BE49-F238E27FC236}">
-                <a16:creationId xmlns:a16="http://schemas.microsoft.com/office/drawing/2014/main" id="{9427C150-CAE0-6F8C-7D69-80665753E1ED}"/>
+                <a16:creationId xmlns:a16="http://schemas.microsoft.com/office/drawing/2014/main" id="{8F1EF7EA-B417-FB1B-F6A7-1737D9743A54}"/>
               </a:ext>
             </a:extLst>
           </p:cNvPr>
@@ -14489,7 +15663,7 @@
           <p:cNvPr id="3" name="Inhaltsplatzhalter 2">
             <a:extLst>
               <a:ext uri="{FF2B5EF4-FFF2-40B4-BE49-F238E27FC236}">
-                <a16:creationId xmlns:a16="http://schemas.microsoft.com/office/drawing/2014/main" id="{50A54A18-5226-100F-AFF5-1FAD1F6C8AD9}"/>
+                <a16:creationId xmlns:a16="http://schemas.microsoft.com/office/drawing/2014/main" id="{18C104A0-8145-78A9-8E4B-7F0FF7C36E51}"/>
               </a:ext>
             </a:extLst>
           </p:cNvPr>
@@ -14579,7 +15753,7 @@
           <p:cNvPr id="4" name="Textplatzhalter 3">
             <a:extLst>
               <a:ext uri="{FF2B5EF4-FFF2-40B4-BE49-F238E27FC236}">
-                <a16:creationId xmlns:a16="http://schemas.microsoft.com/office/drawing/2014/main" id="{4979E677-754F-367E-F157-EABAA6423480}"/>
+                <a16:creationId xmlns:a16="http://schemas.microsoft.com/office/drawing/2014/main" id="{A1ADB249-899B-3B6B-8753-79DD92DBCD86}"/>
               </a:ext>
             </a:extLst>
           </p:cNvPr>
@@ -14650,7 +15824,7 @@
           <p:cNvPr id="5" name="Datumsplatzhalter 4">
             <a:extLst>
               <a:ext uri="{FF2B5EF4-FFF2-40B4-BE49-F238E27FC236}">
-                <a16:creationId xmlns:a16="http://schemas.microsoft.com/office/drawing/2014/main" id="{FD0D80D0-7D7F-BCC5-2F61-8E6CD0BB282F}"/>
+                <a16:creationId xmlns:a16="http://schemas.microsoft.com/office/drawing/2014/main" id="{94F6205E-5621-BAAA-03AD-11FA7261965D}"/>
               </a:ext>
             </a:extLst>
           </p:cNvPr>
@@ -14666,7 +15840,7 @@
           <a:bodyPr/>
           <a:lstStyle/>
           <a:p>
-            <a:fld id="{F90D6D3C-F920-4A3C-B787-1F3E94045D68}" type="datetimeFigureOut">
+            <a:fld id="{5995F78A-EF12-451D-A42D-33BA75944712}" type="datetimeFigureOut">
               <a:rPr lang="de-DE" smtClean="0"/>
               <a:t>08.10.2026</a:t>
             </a:fld>
@@ -14679,7 +15853,7 @@
           <p:cNvPr id="6" name="Fußzeilenplatzhalter 5">
             <a:extLst>
               <a:ext uri="{FF2B5EF4-FFF2-40B4-BE49-F238E27FC236}">
-                <a16:creationId xmlns:a16="http://schemas.microsoft.com/office/drawing/2014/main" id="{9C848E5D-8D61-BF9F-A854-1AE0F62ACF2D}"/>
+                <a16:creationId xmlns:a16="http://schemas.microsoft.com/office/drawing/2014/main" id="{D398EA9D-AC06-FA88-6F98-0F8C56CFC5CE}"/>
               </a:ext>
             </a:extLst>
           </p:cNvPr>
@@ -14704,7 +15878,7 @@
           <p:cNvPr id="7" name="Foliennummernplatzhalter 6">
             <a:extLst>
               <a:ext uri="{FF2B5EF4-FFF2-40B4-BE49-F238E27FC236}">
-                <a16:creationId xmlns:a16="http://schemas.microsoft.com/office/drawing/2014/main" id="{6C7B05C6-52D2-7508-2F15-76C09826E786}"/>
+                <a16:creationId xmlns:a16="http://schemas.microsoft.com/office/drawing/2014/main" id="{86BF8462-194B-D214-4893-1213016FFD73}"/>
               </a:ext>
             </a:extLst>
           </p:cNvPr>
@@ -14720,7 +15894,7 @@
           <a:bodyPr/>
           <a:lstStyle/>
           <a:p>
-            <a:fld id="{AF894DF6-4592-44C9-97EF-4B210170B4D6}" type="slidenum">
+            <a:fld id="{58E1AFF0-AF8B-46F6-A11A-4CAC28041454}" type="slidenum">
               <a:rPr lang="de-DE" smtClean="0"/>
               <a:t>‹Nr.›</a:t>
             </a:fld>
@@ -14731,7 +15905,7 @@
     </p:spTree>
     <p:extLst>
       <p:ext uri="{BB962C8B-B14F-4D97-AF65-F5344CB8AC3E}">
-        <p14:creationId xmlns:p14="http://schemas.microsoft.com/office/powerpoint/2010/main" val="987659781"/>
+        <p14:creationId xmlns:p14="http://schemas.microsoft.com/office/powerpoint/2010/main" val="892885658"/>
       </p:ext>
     </p:extLst>
   </p:cSld>
@@ -14763,7 +15937,7 @@
           <p:cNvPr id="2" name="Titel 1">
             <a:extLst>
               <a:ext uri="{FF2B5EF4-FFF2-40B4-BE49-F238E27FC236}">
-                <a16:creationId xmlns:a16="http://schemas.microsoft.com/office/drawing/2014/main" id="{2D9DEC9A-0D4F-B3DD-128E-29DBE612738F}"/>
+                <a16:creationId xmlns:a16="http://schemas.microsoft.com/office/drawing/2014/main" id="{CBBF291A-4346-6F1B-1CA1-54F30DC6B0CC}"/>
               </a:ext>
             </a:extLst>
           </p:cNvPr>
@@ -14800,7 +15974,7 @@
           <p:cNvPr id="3" name="Bildplatzhalter 2">
             <a:extLst>
               <a:ext uri="{FF2B5EF4-FFF2-40B4-BE49-F238E27FC236}">
-                <a16:creationId xmlns:a16="http://schemas.microsoft.com/office/drawing/2014/main" id="{75ADD9D5-B493-C4A3-D32B-A66B447306F6}"/>
+                <a16:creationId xmlns:a16="http://schemas.microsoft.com/office/drawing/2014/main" id="{C9C743FA-094A-03DA-BF2D-85BEFE734CD5}"/>
               </a:ext>
             </a:extLst>
           </p:cNvPr>
@@ -14867,7 +16041,7 @@
           <p:cNvPr id="4" name="Textplatzhalter 3">
             <a:extLst>
               <a:ext uri="{FF2B5EF4-FFF2-40B4-BE49-F238E27FC236}">
-                <a16:creationId xmlns:a16="http://schemas.microsoft.com/office/drawing/2014/main" id="{7EB7ABD2-E8FE-FA5A-FF3D-51EB8E7508FE}"/>
+                <a16:creationId xmlns:a16="http://schemas.microsoft.com/office/drawing/2014/main" id="{71FFB036-36E9-A07A-60C3-3226C4AA8E86}"/>
               </a:ext>
             </a:extLst>
           </p:cNvPr>
@@ -14938,7 +16112,7 @@
           <p:cNvPr id="5" name="Datumsplatzhalter 4">
             <a:extLst>
               <a:ext uri="{FF2B5EF4-FFF2-40B4-BE49-F238E27FC236}">
-                <a16:creationId xmlns:a16="http://schemas.microsoft.com/office/drawing/2014/main" id="{06E69214-52A9-DB1B-3A2D-95B76560968E}"/>
+                <a16:creationId xmlns:a16="http://schemas.microsoft.com/office/drawing/2014/main" id="{0D32834A-43B5-8A66-51C8-FECCB80D489D}"/>
               </a:ext>
             </a:extLst>
           </p:cNvPr>
@@ -14954,7 +16128,7 @@
           <a:bodyPr/>
           <a:lstStyle/>
           <a:p>
-            <a:fld id="{F90D6D3C-F920-4A3C-B787-1F3E94045D68}" type="datetimeFigureOut">
+            <a:fld id="{5995F78A-EF12-451D-A42D-33BA75944712}" type="datetimeFigureOut">
               <a:rPr lang="de-DE" smtClean="0"/>
               <a:t>08.10.2026</a:t>
             </a:fld>
@@ -14967,7 +16141,7 @@
           <p:cNvPr id="6" name="Fußzeilenplatzhalter 5">
             <a:extLst>
               <a:ext uri="{FF2B5EF4-FFF2-40B4-BE49-F238E27FC236}">
-                <a16:creationId xmlns:a16="http://schemas.microsoft.com/office/drawing/2014/main" id="{E47765F0-BF3D-41A7-0AB3-F3BE9577F036}"/>
+                <a16:creationId xmlns:a16="http://schemas.microsoft.com/office/drawing/2014/main" id="{CDC42061-9826-E696-F496-12F9FD1DBAAB}"/>
               </a:ext>
             </a:extLst>
           </p:cNvPr>
@@ -14992,7 +16166,7 @@
           <p:cNvPr id="7" name="Foliennummernplatzhalter 6">
             <a:extLst>
               <a:ext uri="{FF2B5EF4-FFF2-40B4-BE49-F238E27FC236}">
-                <a16:creationId xmlns:a16="http://schemas.microsoft.com/office/drawing/2014/main" id="{EEECA688-09C2-120B-5240-72121090B773}"/>
+                <a16:creationId xmlns:a16="http://schemas.microsoft.com/office/drawing/2014/main" id="{BFAE6900-CC9A-12CE-FF7E-C56CB6150A9A}"/>
               </a:ext>
             </a:extLst>
           </p:cNvPr>
@@ -15008,7 +16182,7 @@
           <a:bodyPr/>
           <a:lstStyle/>
           <a:p>
-            <a:fld id="{AF894DF6-4592-44C9-97EF-4B210170B4D6}" type="slidenum">
+            <a:fld id="{58E1AFF0-AF8B-46F6-A11A-4CAC28041454}" type="slidenum">
               <a:rPr lang="de-DE" smtClean="0"/>
               <a:t>‹Nr.›</a:t>
             </a:fld>
@@ -15019,7 +16193,7 @@
     </p:spTree>
     <p:extLst>
       <p:ext uri="{BB962C8B-B14F-4D97-AF65-F5344CB8AC3E}">
-        <p14:creationId xmlns:p14="http://schemas.microsoft.com/office/powerpoint/2010/main" val="135122650"/>
+        <p14:creationId xmlns:p14="http://schemas.microsoft.com/office/powerpoint/2010/main" val="3722114766"/>
       </p:ext>
     </p:extLst>
   </p:cSld>
@@ -15056,7 +16230,7 @@
           <p:cNvPr id="2" name="Titelplatzhalter 1">
             <a:extLst>
               <a:ext uri="{FF2B5EF4-FFF2-40B4-BE49-F238E27FC236}">
-                <a16:creationId xmlns:a16="http://schemas.microsoft.com/office/drawing/2014/main" id="{4B17DC92-218A-B71C-708A-A3DFE7251F61}"/>
+                <a16:creationId xmlns:a16="http://schemas.microsoft.com/office/drawing/2014/main" id="{C9FF5996-350D-1AEA-7199-380D7BD9A0A3}"/>
               </a:ext>
             </a:extLst>
           </p:cNvPr>
@@ -15094,7 +16268,7 @@
           <p:cNvPr id="3" name="Textplatzhalter 2">
             <a:extLst>
               <a:ext uri="{FF2B5EF4-FFF2-40B4-BE49-F238E27FC236}">
-                <a16:creationId xmlns:a16="http://schemas.microsoft.com/office/drawing/2014/main" id="{A5796F98-FADB-7E15-54E9-C58DD954B783}"/>
+                <a16:creationId xmlns:a16="http://schemas.microsoft.com/office/drawing/2014/main" id="{CC174A53-105A-30BA-7AAD-2E2AD47DDC8D}"/>
               </a:ext>
             </a:extLst>
           </p:cNvPr>
@@ -15161,7 +16335,7 @@
           <p:cNvPr id="4" name="Datumsplatzhalter 3">
             <a:extLst>
               <a:ext uri="{FF2B5EF4-FFF2-40B4-BE49-F238E27FC236}">
-                <a16:creationId xmlns:a16="http://schemas.microsoft.com/office/drawing/2014/main" id="{16A76F21-5AE6-437F-B53D-828E5C6AA4B8}"/>
+                <a16:creationId xmlns:a16="http://schemas.microsoft.com/office/drawing/2014/main" id="{DE466C58-14E6-A53D-4156-CD4D447F929E}"/>
               </a:ext>
             </a:extLst>
           </p:cNvPr>
@@ -15195,7 +16369,7 @@
             </a:lvl1pPr>
           </a:lstStyle>
           <a:p>
-            <a:fld id="{F90D6D3C-F920-4A3C-B787-1F3E94045D68}" type="datetimeFigureOut">
+            <a:fld id="{5995F78A-EF12-451D-A42D-33BA75944712}" type="datetimeFigureOut">
               <a:rPr lang="de-DE" smtClean="0"/>
               <a:t>08.10.2026</a:t>
             </a:fld>
@@ -15208,7 +16382,7 @@
           <p:cNvPr id="5" name="Fußzeilenplatzhalter 4">
             <a:extLst>
               <a:ext uri="{FF2B5EF4-FFF2-40B4-BE49-F238E27FC236}">
-                <a16:creationId xmlns:a16="http://schemas.microsoft.com/office/drawing/2014/main" id="{FECA72CF-59A4-6A70-5224-FE203A0DFD4B}"/>
+                <a16:creationId xmlns:a16="http://schemas.microsoft.com/office/drawing/2014/main" id="{EABBE4A9-6877-8AD5-A6CF-98E9EBAE42FA}"/>
               </a:ext>
             </a:extLst>
           </p:cNvPr>
@@ -15251,7 +16425,7 @@
           <p:cNvPr id="6" name="Foliennummernplatzhalter 5">
             <a:extLst>
               <a:ext uri="{FF2B5EF4-FFF2-40B4-BE49-F238E27FC236}">
-                <a16:creationId xmlns:a16="http://schemas.microsoft.com/office/drawing/2014/main" id="{ABCA2A17-0884-24D4-6DFE-E81BD6B09B2B}"/>
+                <a16:creationId xmlns:a16="http://schemas.microsoft.com/office/drawing/2014/main" id="{BE01B096-709C-43AE-E6FF-B4C975F1D756}"/>
               </a:ext>
             </a:extLst>
           </p:cNvPr>
@@ -15285,7 +16459,7 @@
             </a:lvl1pPr>
           </a:lstStyle>
           <a:p>
-            <a:fld id="{AF894DF6-4592-44C9-97EF-4B210170B4D6}" type="slidenum">
+            <a:fld id="{58E1AFF0-AF8B-46F6-A11A-4CAC28041454}" type="slidenum">
               <a:rPr lang="de-DE" smtClean="0"/>
               <a:t>‹Nr.›</a:t>
             </a:fld>
@@ -15296,7 +16470,7 @@
     </p:spTree>
     <p:extLst>
       <p:ext uri="{BB962C8B-B14F-4D97-AF65-F5344CB8AC3E}">
-        <p14:creationId xmlns:p14="http://schemas.microsoft.com/office/powerpoint/2010/main" val="2348071395"/>
+        <p14:creationId xmlns:p14="http://schemas.microsoft.com/office/powerpoint/2010/main" val="260080551"/>
       </p:ext>
     </p:extLst>
   </p:cSld>
@@ -15619,7 +16793,7 @@
           <p:cNvPr id="2" name="Titel 1">
             <a:extLst>
               <a:ext uri="{FF2B5EF4-FFF2-40B4-BE49-F238E27FC236}">
-                <a16:creationId xmlns:a16="http://schemas.microsoft.com/office/drawing/2014/main" id="{046D7D81-9D0C-A495-678D-2DC7CB812226}"/>
+                <a16:creationId xmlns:a16="http://schemas.microsoft.com/office/drawing/2014/main" id="{E03B6F84-CF67-1BDD-656E-3D08E04B9EF6}"/>
               </a:ext>
             </a:extLst>
           </p:cNvPr>
@@ -15647,7 +16821,7 @@
           <p:cNvPr id="3" name="Diagramm 2">
             <a:extLst>
               <a:ext uri="{FF2B5EF4-FFF2-40B4-BE49-F238E27FC236}">
-                <a16:creationId xmlns:a16="http://schemas.microsoft.com/office/drawing/2014/main" id="{5BE7E4EC-5931-88A2-D28D-47699F026FF5}"/>
+                <a16:creationId xmlns:a16="http://schemas.microsoft.com/office/drawing/2014/main" id="{E0435B8F-A3EC-6451-EED3-D59C09053A7C}"/>
               </a:ext>
             </a:extLst>
           </p:cNvPr>
@@ -15655,7 +16829,7 @@
           <p:nvPr>
             <p:extLst>
               <p:ext uri="{D42A27DB-BD31-4B8C-83A1-F6EECF244321}">
-                <p14:modId xmlns:p14="http://schemas.microsoft.com/office/powerpoint/2010/main" val="4288122339"/>
+                <p14:modId xmlns:p14="http://schemas.microsoft.com/office/powerpoint/2010/main" val="3139251124"/>
               </p:ext>
             </p:extLst>
           </p:nvPr>
@@ -15675,7 +16849,7 @@
           <p:cNvPr id="4" name="Diagramm 3">
             <a:extLst>
               <a:ext uri="{FF2B5EF4-FFF2-40B4-BE49-F238E27FC236}">
-                <a16:creationId xmlns:a16="http://schemas.microsoft.com/office/drawing/2014/main" id="{80B41AAA-A2C2-5170-3C8A-DEED070590A5}"/>
+                <a16:creationId xmlns:a16="http://schemas.microsoft.com/office/drawing/2014/main" id="{90E8925A-E14D-6869-AD4F-4D22CF3CCE03}"/>
               </a:ext>
             </a:extLst>
           </p:cNvPr>
@@ -15683,7 +16857,7 @@
           <p:nvPr>
             <p:extLst>
               <p:ext uri="{D42A27DB-BD31-4B8C-83A1-F6EECF244321}">
-                <p14:modId xmlns:p14="http://schemas.microsoft.com/office/powerpoint/2010/main" val="3032808018"/>
+                <p14:modId xmlns:p14="http://schemas.microsoft.com/office/powerpoint/2010/main" val="3905979681"/>
               </p:ext>
             </p:extLst>
           </p:nvPr>
@@ -15701,7 +16875,7 @@
     </p:spTree>
     <p:extLst>
       <p:ext uri="{BB962C8B-B14F-4D97-AF65-F5344CB8AC3E}">
-        <p14:creationId xmlns:p14="http://schemas.microsoft.com/office/powerpoint/2010/main" val="3242287177"/>
+        <p14:creationId xmlns:p14="http://schemas.microsoft.com/office/powerpoint/2010/main" val="2189348572"/>
       </p:ext>
     </p:extLst>
   </p:cSld>
@@ -15733,7 +16907,7 @@
           <p:cNvPr id="2" name="Titel 1">
             <a:extLst>
               <a:ext uri="{FF2B5EF4-FFF2-40B4-BE49-F238E27FC236}">
-                <a16:creationId xmlns:a16="http://schemas.microsoft.com/office/drawing/2014/main" id="{CBC6A413-9638-6F4B-A296-80633792D450}"/>
+                <a16:creationId xmlns:a16="http://schemas.microsoft.com/office/drawing/2014/main" id="{B55CED64-413F-DDD2-3D20-34846CF627BA}"/>
               </a:ext>
             </a:extLst>
           </p:cNvPr>
@@ -15761,7 +16935,7 @@
           <p:cNvPr id="3" name="Diagramm 2">
             <a:extLst>
               <a:ext uri="{FF2B5EF4-FFF2-40B4-BE49-F238E27FC236}">
-                <a16:creationId xmlns:a16="http://schemas.microsoft.com/office/drawing/2014/main" id="{C5663641-E8C4-307E-E7CE-032E246CA544}"/>
+                <a16:creationId xmlns:a16="http://schemas.microsoft.com/office/drawing/2014/main" id="{C301A46B-83E8-549D-03F8-536B91DB1F71}"/>
               </a:ext>
             </a:extLst>
           </p:cNvPr>
@@ -15769,7 +16943,7 @@
           <p:nvPr>
             <p:extLst>
               <p:ext uri="{D42A27DB-BD31-4B8C-83A1-F6EECF244321}">
-                <p14:modId xmlns:p14="http://schemas.microsoft.com/office/powerpoint/2010/main" val="2869581489"/>
+                <p14:modId xmlns:p14="http://schemas.microsoft.com/office/powerpoint/2010/main" val="390276154"/>
               </p:ext>
             </p:extLst>
           </p:nvPr>
@@ -15789,7 +16963,7 @@
           <p:cNvPr id="4" name="Diagramm 3">
             <a:extLst>
               <a:ext uri="{FF2B5EF4-FFF2-40B4-BE49-F238E27FC236}">
-                <a16:creationId xmlns:a16="http://schemas.microsoft.com/office/drawing/2014/main" id="{6A096D50-1F92-DCF4-AB38-E2C8D5ECB3AD}"/>
+                <a16:creationId xmlns:a16="http://schemas.microsoft.com/office/drawing/2014/main" id="{17EA03CD-B100-75ED-6857-882371797810}"/>
               </a:ext>
             </a:extLst>
           </p:cNvPr>
@@ -15797,7 +16971,7 @@
           <p:nvPr>
             <p:extLst>
               <p:ext uri="{D42A27DB-BD31-4B8C-83A1-F6EECF244321}">
-                <p14:modId xmlns:p14="http://schemas.microsoft.com/office/powerpoint/2010/main" val="2123878281"/>
+                <p14:modId xmlns:p14="http://schemas.microsoft.com/office/powerpoint/2010/main" val="4156545360"/>
               </p:ext>
             </p:extLst>
           </p:nvPr>
@@ -15815,7 +16989,7 @@
     </p:spTree>
     <p:extLst>
       <p:ext uri="{BB962C8B-B14F-4D97-AF65-F5344CB8AC3E}">
-        <p14:creationId xmlns:p14="http://schemas.microsoft.com/office/powerpoint/2010/main" val="3823952319"/>
+        <p14:creationId xmlns:p14="http://schemas.microsoft.com/office/powerpoint/2010/main" val="1219125134"/>
       </p:ext>
     </p:extLst>
   </p:cSld>
@@ -15847,7 +17021,7 @@
           <p:cNvPr id="2" name="Titel 1">
             <a:extLst>
               <a:ext uri="{FF2B5EF4-FFF2-40B4-BE49-F238E27FC236}">
-                <a16:creationId xmlns:a16="http://schemas.microsoft.com/office/drawing/2014/main" id="{0AAF4646-A1B2-6D32-1C30-CFC17E556B68}"/>
+                <a16:creationId xmlns:a16="http://schemas.microsoft.com/office/drawing/2014/main" id="{D54B6D82-0543-2094-DDC5-83B148EFEC10}"/>
               </a:ext>
             </a:extLst>
           </p:cNvPr>
@@ -15875,7 +17049,7 @@
           <p:cNvPr id="3" name="Diagramm 2">
             <a:extLst>
               <a:ext uri="{FF2B5EF4-FFF2-40B4-BE49-F238E27FC236}">
-                <a16:creationId xmlns:a16="http://schemas.microsoft.com/office/drawing/2014/main" id="{CF164ABF-8EE0-0B97-7D9C-EFC600524F19}"/>
+                <a16:creationId xmlns:a16="http://schemas.microsoft.com/office/drawing/2014/main" id="{C81F349F-90A1-CCF3-951F-AD25F0377C0A}"/>
               </a:ext>
             </a:extLst>
           </p:cNvPr>
@@ -15883,7 +17057,7 @@
           <p:nvPr>
             <p:extLst>
               <p:ext uri="{D42A27DB-BD31-4B8C-83A1-F6EECF244321}">
-                <p14:modId xmlns:p14="http://schemas.microsoft.com/office/powerpoint/2010/main" val="673705708"/>
+                <p14:modId xmlns:p14="http://schemas.microsoft.com/office/powerpoint/2010/main" val="1972944085"/>
               </p:ext>
             </p:extLst>
           </p:nvPr>
@@ -15901,7 +17075,7 @@
     </p:spTree>
     <p:extLst>
       <p:ext uri="{BB962C8B-B14F-4D97-AF65-F5344CB8AC3E}">
-        <p14:creationId xmlns:p14="http://schemas.microsoft.com/office/powerpoint/2010/main" val="1501037086"/>
+        <p14:creationId xmlns:p14="http://schemas.microsoft.com/office/powerpoint/2010/main" val="4156345538"/>
       </p:ext>
     </p:extLst>
   </p:cSld>
@@ -15933,7 +17107,7 @@
           <p:cNvPr id="2" name="Titel 1">
             <a:extLst>
               <a:ext uri="{FF2B5EF4-FFF2-40B4-BE49-F238E27FC236}">
-                <a16:creationId xmlns:a16="http://schemas.microsoft.com/office/drawing/2014/main" id="{A5FF7FF3-EC60-ECDF-D57D-859514AD5CC4}"/>
+                <a16:creationId xmlns:a16="http://schemas.microsoft.com/office/drawing/2014/main" id="{7D25024F-02AA-B9B8-B6B9-9AE2A17FA117}"/>
               </a:ext>
             </a:extLst>
           </p:cNvPr>
@@ -15961,7 +17135,7 @@
           <p:cNvPr id="3" name="Diagramm 2">
             <a:extLst>
               <a:ext uri="{FF2B5EF4-FFF2-40B4-BE49-F238E27FC236}">
-                <a16:creationId xmlns:a16="http://schemas.microsoft.com/office/drawing/2014/main" id="{D75BB32D-01C4-8C14-459A-C285A39FA02B}"/>
+                <a16:creationId xmlns:a16="http://schemas.microsoft.com/office/drawing/2014/main" id="{76A55E58-DFDA-0AD6-7860-2C5F9523F477}"/>
               </a:ext>
             </a:extLst>
           </p:cNvPr>
@@ -15969,7 +17143,7 @@
           <p:nvPr>
             <p:extLst>
               <p:ext uri="{D42A27DB-BD31-4B8C-83A1-F6EECF244321}">
-                <p14:modId xmlns:p14="http://schemas.microsoft.com/office/powerpoint/2010/main" val="1998179472"/>
+                <p14:modId xmlns:p14="http://schemas.microsoft.com/office/powerpoint/2010/main" val="3860479111"/>
               </p:ext>
             </p:extLst>
           </p:nvPr>
@@ -15989,7 +17163,7 @@
           <p:cNvPr id="4" name="Diagramm 3">
             <a:extLst>
               <a:ext uri="{FF2B5EF4-FFF2-40B4-BE49-F238E27FC236}">
-                <a16:creationId xmlns:a16="http://schemas.microsoft.com/office/drawing/2014/main" id="{0F4348A9-AAF5-4836-F25C-B0AD9CE4F8F1}"/>
+                <a16:creationId xmlns:a16="http://schemas.microsoft.com/office/drawing/2014/main" id="{7310E2D1-C0CC-BC82-B3A7-5AF39DD0F567}"/>
               </a:ext>
             </a:extLst>
           </p:cNvPr>
@@ -15997,7 +17171,7 @@
           <p:nvPr>
             <p:extLst>
               <p:ext uri="{D42A27DB-BD31-4B8C-83A1-F6EECF244321}">
-                <p14:modId xmlns:p14="http://schemas.microsoft.com/office/powerpoint/2010/main" val="3997686721"/>
+                <p14:modId xmlns:p14="http://schemas.microsoft.com/office/powerpoint/2010/main" val="2963793935"/>
               </p:ext>
             </p:extLst>
           </p:nvPr>
@@ -16015,7 +17189,7 @@
     </p:spTree>
     <p:extLst>
       <p:ext uri="{BB962C8B-B14F-4D97-AF65-F5344CB8AC3E}">
-        <p14:creationId xmlns:p14="http://schemas.microsoft.com/office/powerpoint/2010/main" val="2396539445"/>
+        <p14:creationId xmlns:p14="http://schemas.microsoft.com/office/powerpoint/2010/main" val="4079892508"/>
       </p:ext>
     </p:extLst>
   </p:cSld>
@@ -16047,7 +17221,7 @@
           <p:cNvPr id="2" name="Titel 1">
             <a:extLst>
               <a:ext uri="{FF2B5EF4-FFF2-40B4-BE49-F238E27FC236}">
-                <a16:creationId xmlns:a16="http://schemas.microsoft.com/office/drawing/2014/main" id="{66FB1ED9-C340-6BFB-A278-FB9B1D4CE9D5}"/>
+                <a16:creationId xmlns:a16="http://schemas.microsoft.com/office/drawing/2014/main" id="{5F951B87-7C8D-F121-4D3C-39574B65FA36}"/>
               </a:ext>
             </a:extLst>
           </p:cNvPr>
@@ -16075,7 +17249,7 @@
           <p:cNvPr id="3" name="Diagramm 2">
             <a:extLst>
               <a:ext uri="{FF2B5EF4-FFF2-40B4-BE49-F238E27FC236}">
-                <a16:creationId xmlns:a16="http://schemas.microsoft.com/office/drawing/2014/main" id="{59D70646-AB03-B19A-640E-B544C2D2CD1E}"/>
+                <a16:creationId xmlns:a16="http://schemas.microsoft.com/office/drawing/2014/main" id="{E8B9D1FD-87AD-59EA-7B48-4CAEE895262E}"/>
               </a:ext>
             </a:extLst>
           </p:cNvPr>
@@ -16083,7 +17257,7 @@
           <p:nvPr>
             <p:extLst>
               <p:ext uri="{D42A27DB-BD31-4B8C-83A1-F6EECF244321}">
-                <p14:modId xmlns:p14="http://schemas.microsoft.com/office/powerpoint/2010/main" val="545807593"/>
+                <p14:modId xmlns:p14="http://schemas.microsoft.com/office/powerpoint/2010/main" val="1222018219"/>
               </p:ext>
             </p:extLst>
           </p:nvPr>
@@ -16103,7 +17277,7 @@
           <p:cNvPr id="4" name="Diagramm 3">
             <a:extLst>
               <a:ext uri="{FF2B5EF4-FFF2-40B4-BE49-F238E27FC236}">
-                <a16:creationId xmlns:a16="http://schemas.microsoft.com/office/drawing/2014/main" id="{8C702D9A-2559-1D29-AAAF-63665E4CAC02}"/>
+                <a16:creationId xmlns:a16="http://schemas.microsoft.com/office/drawing/2014/main" id="{1AF7D66D-65BE-4EE7-8C2E-9DD17AC379E5}"/>
               </a:ext>
             </a:extLst>
           </p:cNvPr>
@@ -16111,7 +17285,7 @@
           <p:nvPr>
             <p:extLst>
               <p:ext uri="{D42A27DB-BD31-4B8C-83A1-F6EECF244321}">
-                <p14:modId xmlns:p14="http://schemas.microsoft.com/office/powerpoint/2010/main" val="1594522263"/>
+                <p14:modId xmlns:p14="http://schemas.microsoft.com/office/powerpoint/2010/main" val="3252780657"/>
               </p:ext>
             </p:extLst>
           </p:nvPr>
@@ -16129,7 +17303,7 @@
     </p:spTree>
     <p:extLst>
       <p:ext uri="{BB962C8B-B14F-4D97-AF65-F5344CB8AC3E}">
-        <p14:creationId xmlns:p14="http://schemas.microsoft.com/office/powerpoint/2010/main" val="1143447370"/>
+        <p14:creationId xmlns:p14="http://schemas.microsoft.com/office/powerpoint/2010/main" val="4215311852"/>
       </p:ext>
     </p:extLst>
   </p:cSld>
@@ -16161,7 +17335,7 @@
           <p:cNvPr id="2" name="Titel 1">
             <a:extLst>
               <a:ext uri="{FF2B5EF4-FFF2-40B4-BE49-F238E27FC236}">
-                <a16:creationId xmlns:a16="http://schemas.microsoft.com/office/drawing/2014/main" id="{1557C53B-6CBE-6B52-07D0-AA7F40654FE6}"/>
+                <a16:creationId xmlns:a16="http://schemas.microsoft.com/office/drawing/2014/main" id="{C9D3FA6D-8753-B255-E9B8-5D7E4E03A37E}"/>
               </a:ext>
             </a:extLst>
           </p:cNvPr>
@@ -16191,7 +17365,7 @@
               <p:cNvPr id="3" name="Diagramm 2">
                 <a:extLst>
                   <a:ext uri="{FF2B5EF4-FFF2-40B4-BE49-F238E27FC236}">
-                    <a16:creationId xmlns:a16="http://schemas.microsoft.com/office/drawing/2014/main" id="{463F2ABD-81AE-7781-8328-DA1278F56C00}"/>
+                    <a16:creationId xmlns:a16="http://schemas.microsoft.com/office/drawing/2014/main" id="{08870866-FD23-A9BF-6D81-CBD2BCE14E49}"/>
                   </a:ext>
                 </a:extLst>
               </p:cNvPr>
@@ -16199,7 +17373,7 @@
               <p:nvPr>
                 <p:extLst>
                   <p:ext uri="{D42A27DB-BD31-4B8C-83A1-F6EECF244321}">
-                    <p14:modId xmlns:p14="http://schemas.microsoft.com/office/powerpoint/2010/main" val="3779423131"/>
+                    <p14:modId xmlns:p14="http://schemas.microsoft.com/office/powerpoint/2010/main" val="50116877"/>
                   </p:ext>
                 </p:extLst>
               </p:nvPr>
@@ -16221,7 +17395,7 @@
               <p:cNvPr id="3" name="Diagramm 2">
                 <a:extLst>
                   <a:ext uri="{FF2B5EF4-FFF2-40B4-BE49-F238E27FC236}">
-                    <a16:creationId xmlns:a16="http://schemas.microsoft.com/office/drawing/2014/main" id="{463F2ABD-81AE-7781-8328-DA1278F56C00}"/>
+                    <a16:creationId xmlns:a16="http://schemas.microsoft.com/office/drawing/2014/main" id="{08870866-FD23-A9BF-6D81-CBD2BCE14E49}"/>
                   </a:ext>
                 </a:extLst>
               </p:cNvPr>
@@ -16255,7 +17429,7 @@
               <p:cNvPr id="4" name="Diagramm 3">
                 <a:extLst>
                   <a:ext uri="{FF2B5EF4-FFF2-40B4-BE49-F238E27FC236}">
-                    <a16:creationId xmlns:a16="http://schemas.microsoft.com/office/drawing/2014/main" id="{B744F78E-3486-1911-1BCC-9BEE726AD873}"/>
+                    <a16:creationId xmlns:a16="http://schemas.microsoft.com/office/drawing/2014/main" id="{0AA07062-D016-F78F-50D3-CCBA06D7B924}"/>
                   </a:ext>
                 </a:extLst>
               </p:cNvPr>
@@ -16263,7 +17437,7 @@
               <p:nvPr>
                 <p:extLst>
                   <p:ext uri="{D42A27DB-BD31-4B8C-83A1-F6EECF244321}">
-                    <p14:modId xmlns:p14="http://schemas.microsoft.com/office/powerpoint/2010/main" val="4047115379"/>
+                    <p14:modId xmlns:p14="http://schemas.microsoft.com/office/powerpoint/2010/main" val="3443521495"/>
                   </p:ext>
                 </p:extLst>
               </p:nvPr>
@@ -16285,7 +17459,7 @@
               <p:cNvPr id="4" name="Diagramm 3">
                 <a:extLst>
                   <a:ext uri="{FF2B5EF4-FFF2-40B4-BE49-F238E27FC236}">
-                    <a16:creationId xmlns:a16="http://schemas.microsoft.com/office/drawing/2014/main" id="{B744F78E-3486-1911-1BCC-9BEE726AD873}"/>
+                    <a16:creationId xmlns:a16="http://schemas.microsoft.com/office/drawing/2014/main" id="{0AA07062-D016-F78F-50D3-CCBA06D7B924}"/>
                   </a:ext>
                 </a:extLst>
               </p:cNvPr>
@@ -16319,7 +17493,7 @@
               <p:cNvPr id="5" name="Diagramm 4">
                 <a:extLst>
                   <a:ext uri="{FF2B5EF4-FFF2-40B4-BE49-F238E27FC236}">
-                    <a16:creationId xmlns:a16="http://schemas.microsoft.com/office/drawing/2014/main" id="{E3E62ED1-EB50-CDC3-686A-9AB441F5E329}"/>
+                    <a16:creationId xmlns:a16="http://schemas.microsoft.com/office/drawing/2014/main" id="{D3D48656-4C60-CD52-658E-0B6A689AE286}"/>
                   </a:ext>
                 </a:extLst>
               </p:cNvPr>
@@ -16327,7 +17501,7 @@
               <p:nvPr>
                 <p:extLst>
                   <p:ext uri="{D42A27DB-BD31-4B8C-83A1-F6EECF244321}">
-                    <p14:modId xmlns:p14="http://schemas.microsoft.com/office/powerpoint/2010/main" val="2251627858"/>
+                    <p14:modId xmlns:p14="http://schemas.microsoft.com/office/powerpoint/2010/main" val="3951042648"/>
                   </p:ext>
                 </p:extLst>
               </p:nvPr>
@@ -16349,7 +17523,7 @@
               <p:cNvPr id="5" name="Diagramm 4">
                 <a:extLst>
                   <a:ext uri="{FF2B5EF4-FFF2-40B4-BE49-F238E27FC236}">
-                    <a16:creationId xmlns:a16="http://schemas.microsoft.com/office/drawing/2014/main" id="{E3E62ED1-EB50-CDC3-686A-9AB441F5E329}"/>
+                    <a16:creationId xmlns:a16="http://schemas.microsoft.com/office/drawing/2014/main" id="{D3D48656-4C60-CD52-658E-0B6A689AE286}"/>
                   </a:ext>
                 </a:extLst>
               </p:cNvPr>
@@ -16379,7 +17553,7 @@
     </p:spTree>
     <p:extLst>
       <p:ext uri="{BB962C8B-B14F-4D97-AF65-F5344CB8AC3E}">
-        <p14:creationId xmlns:p14="http://schemas.microsoft.com/office/powerpoint/2010/main" val="2640435859"/>
+        <p14:creationId xmlns:p14="http://schemas.microsoft.com/office/powerpoint/2010/main" val="1131394498"/>
       </p:ext>
     </p:extLst>
   </p:cSld>
@@ -16411,7 +17585,7 @@
           <p:cNvPr id="2" name="Titel 1">
             <a:extLst>
               <a:ext uri="{FF2B5EF4-FFF2-40B4-BE49-F238E27FC236}">
-                <a16:creationId xmlns:a16="http://schemas.microsoft.com/office/drawing/2014/main" id="{BDF72264-D15C-9985-438F-3DEE76CB0D80}"/>
+                <a16:creationId xmlns:a16="http://schemas.microsoft.com/office/drawing/2014/main" id="{0FA0AF31-A5B1-DF87-E021-3C182722E51B}"/>
               </a:ext>
             </a:extLst>
           </p:cNvPr>
@@ -16442,7 +17616,7 @@
               <p:cNvPr id="3" name="Diagramm 2">
                 <a:extLst>
                   <a:ext uri="{FF2B5EF4-FFF2-40B4-BE49-F238E27FC236}">
-                    <a16:creationId xmlns:a16="http://schemas.microsoft.com/office/drawing/2014/main" id="{F7FB91B2-125F-7FEF-F5B6-ABF77474187B}"/>
+                    <a16:creationId xmlns:a16="http://schemas.microsoft.com/office/drawing/2014/main" id="{40422FD9-16EF-1F69-9094-56578A74D6C4}"/>
                   </a:ext>
                 </a:extLst>
               </p:cNvPr>
@@ -16450,7 +17624,7 @@
               <p:nvPr>
                 <p:extLst>
                   <p:ext uri="{D42A27DB-BD31-4B8C-83A1-F6EECF244321}">
-                    <p14:modId xmlns:p14="http://schemas.microsoft.com/office/powerpoint/2010/main" val="3878331701"/>
+                    <p14:modId xmlns:p14="http://schemas.microsoft.com/office/powerpoint/2010/main" val="222711680"/>
                   </p:ext>
                 </p:extLst>
               </p:nvPr>
@@ -16472,7 +17646,7 @@
               <p:cNvPr id="3" name="Diagramm 2">
                 <a:extLst>
                   <a:ext uri="{FF2B5EF4-FFF2-40B4-BE49-F238E27FC236}">
-                    <a16:creationId xmlns:a16="http://schemas.microsoft.com/office/drawing/2014/main" id="{F7FB91B2-125F-7FEF-F5B6-ABF77474187B}"/>
+                    <a16:creationId xmlns:a16="http://schemas.microsoft.com/office/drawing/2014/main" id="{40422FD9-16EF-1F69-9094-56578A74D6C4}"/>
                   </a:ext>
                 </a:extLst>
               </p:cNvPr>
@@ -16506,7 +17680,7 @@
               <p:cNvPr id="4" name="Diagramm 3">
                 <a:extLst>
                   <a:ext uri="{FF2B5EF4-FFF2-40B4-BE49-F238E27FC236}">
-                    <a16:creationId xmlns:a16="http://schemas.microsoft.com/office/drawing/2014/main" id="{25DE527E-BBE0-822B-F9AC-FC99991A1842}"/>
+                    <a16:creationId xmlns:a16="http://schemas.microsoft.com/office/drawing/2014/main" id="{E54001EE-34A6-9382-D572-CC96BD4AF882}"/>
                   </a:ext>
                 </a:extLst>
               </p:cNvPr>
@@ -16514,7 +17688,7 @@
               <p:nvPr>
                 <p:extLst>
                   <p:ext uri="{D42A27DB-BD31-4B8C-83A1-F6EECF244321}">
-                    <p14:modId xmlns:p14="http://schemas.microsoft.com/office/powerpoint/2010/main" val="2956194906"/>
+                    <p14:modId xmlns:p14="http://schemas.microsoft.com/office/powerpoint/2010/main" val="461730159"/>
                   </p:ext>
                 </p:extLst>
               </p:nvPr>
@@ -16536,7 +17710,7 @@
               <p:cNvPr id="4" name="Diagramm 3">
                 <a:extLst>
                   <a:ext uri="{FF2B5EF4-FFF2-40B4-BE49-F238E27FC236}">
-                    <a16:creationId xmlns:a16="http://schemas.microsoft.com/office/drawing/2014/main" id="{25DE527E-BBE0-822B-F9AC-FC99991A1842}"/>
+                    <a16:creationId xmlns:a16="http://schemas.microsoft.com/office/drawing/2014/main" id="{E54001EE-34A6-9382-D572-CC96BD4AF882}"/>
                   </a:ext>
                 </a:extLst>
               </p:cNvPr>
@@ -16570,7 +17744,7 @@
               <p:cNvPr id="5" name="Diagramm 4">
                 <a:extLst>
                   <a:ext uri="{FF2B5EF4-FFF2-40B4-BE49-F238E27FC236}">
-                    <a16:creationId xmlns:a16="http://schemas.microsoft.com/office/drawing/2014/main" id="{AD2338B7-F807-A91E-E4AE-181C6D0C1D58}"/>
+                    <a16:creationId xmlns:a16="http://schemas.microsoft.com/office/drawing/2014/main" id="{E6BE4310-AB3A-3DE0-0084-7389EE51D49C}"/>
                   </a:ext>
                 </a:extLst>
               </p:cNvPr>
@@ -16578,7 +17752,7 @@
               <p:nvPr>
                 <p:extLst>
                   <p:ext uri="{D42A27DB-BD31-4B8C-83A1-F6EECF244321}">
-                    <p14:modId xmlns:p14="http://schemas.microsoft.com/office/powerpoint/2010/main" val="2374409296"/>
+                    <p14:modId xmlns:p14="http://schemas.microsoft.com/office/powerpoint/2010/main" val="3895767891"/>
                   </p:ext>
                 </p:extLst>
               </p:nvPr>
@@ -16600,7 +17774,7 @@
               <p:cNvPr id="5" name="Diagramm 4">
                 <a:extLst>
                   <a:ext uri="{FF2B5EF4-FFF2-40B4-BE49-F238E27FC236}">
-                    <a16:creationId xmlns:a16="http://schemas.microsoft.com/office/drawing/2014/main" id="{AD2338B7-F807-A91E-E4AE-181C6D0C1D58}"/>
+                    <a16:creationId xmlns:a16="http://schemas.microsoft.com/office/drawing/2014/main" id="{E6BE4310-AB3A-3DE0-0084-7389EE51D49C}"/>
                   </a:ext>
                 </a:extLst>
               </p:cNvPr>
@@ -16630,7 +17804,93 @@
     </p:spTree>
     <p:extLst>
       <p:ext uri="{BB962C8B-B14F-4D97-AF65-F5344CB8AC3E}">
-        <p14:creationId xmlns:p14="http://schemas.microsoft.com/office/powerpoint/2010/main" val="2336094138"/>
+        <p14:creationId xmlns:p14="http://schemas.microsoft.com/office/powerpoint/2010/main" val="3950810315"/>
+      </p:ext>
+    </p:extLst>
+  </p:cSld>
+  <p:clrMapOvr>
+    <a:masterClrMapping/>
+  </p:clrMapOvr>
+</p:sld>
+</file>
+
+<file path=ppt/slides/slide8.xml><?xml version="1.0" encoding="utf-8"?>
+<p:sld xmlns:a="http://schemas.openxmlformats.org/drawingml/2006/main" xmlns:r="http://schemas.openxmlformats.org/officeDocument/2006/relationships" xmlns:p="http://schemas.openxmlformats.org/presentationml/2006/main">
+  <p:cSld>
+    <p:spTree>
+      <p:nvGrpSpPr>
+        <p:cNvPr id="1" name=""/>
+        <p:cNvGrpSpPr/>
+        <p:nvPr/>
+      </p:nvGrpSpPr>
+      <p:grpSpPr>
+        <a:xfrm>
+          <a:off x="0" y="0"/>
+          <a:ext cx="0" cy="0"/>
+          <a:chOff x="0" y="0"/>
+          <a:chExt cx="0" cy="0"/>
+        </a:xfrm>
+      </p:grpSpPr>
+      <p:sp>
+        <p:nvSpPr>
+          <p:cNvPr id="2" name="Titel 1">
+            <a:extLst>
+              <a:ext uri="{FF2B5EF4-FFF2-40B4-BE49-F238E27FC236}">
+                <a16:creationId xmlns:a16="http://schemas.microsoft.com/office/drawing/2014/main" id="{8A377DF3-A1AF-D307-9CFA-08B2A6974217}"/>
+              </a:ext>
+            </a:extLst>
+          </p:cNvPr>
+          <p:cNvSpPr>
+            <a:spLocks noGrp="1"/>
+          </p:cNvSpPr>
+          <p:nvPr>
+            <p:ph type="title"/>
+          </p:nvPr>
+        </p:nvSpPr>
+        <p:spPr/>
+        <p:txBody>
+          <a:bodyPr/>
+          <a:lstStyle/>
+          <a:p>
+            <a:r>
+              <a:rPr lang="de-DE"/>
+              <a:t>Shapes on a chart</a:t>
+            </a:r>
+          </a:p>
+        </p:txBody>
+      </p:sp>
+      <p:graphicFrame>
+        <p:nvGraphicFramePr>
+          <p:cNvPr id="3" name="Diagramm 2">
+            <a:extLst>
+              <a:ext uri="{FF2B5EF4-FFF2-40B4-BE49-F238E27FC236}">
+                <a16:creationId xmlns:a16="http://schemas.microsoft.com/office/drawing/2014/main" id="{2915F768-212E-A7A4-36BF-214C34BB64A8}"/>
+              </a:ext>
+            </a:extLst>
+          </p:cNvPr>
+          <p:cNvGraphicFramePr/>
+          <p:nvPr>
+            <p:extLst>
+              <p:ext uri="{D42A27DB-BD31-4B8C-83A1-F6EECF244321}">
+                <p14:modId xmlns:p14="http://schemas.microsoft.com/office/powerpoint/2010/main" val="3930851063"/>
+              </p:ext>
+            </p:extLst>
+          </p:nvPr>
+        </p:nvGraphicFramePr>
+        <p:xfrm>
+          <a:off x="1016000" y="1397000"/>
+          <a:ext cx="8890000" cy="5080000"/>
+        </p:xfrm>
+        <a:graphic>
+          <a:graphicData uri="http://schemas.openxmlformats.org/drawingml/2006/chart">
+            <c:chart xmlns:c="http://schemas.openxmlformats.org/drawingml/2006/chart" xmlns:r="http://schemas.openxmlformats.org/officeDocument/2006/relationships" r:id="rId2"/>
+          </a:graphicData>
+        </a:graphic>
+      </p:graphicFrame>
+    </p:spTree>
+    <p:extLst>
+      <p:ext uri="{BB962C8B-B14F-4D97-AF65-F5344CB8AC3E}">
+        <p14:creationId xmlns:p14="http://schemas.microsoft.com/office/powerpoint/2010/main" val="1746331488"/>
       </p:ext>
     </p:extLst>
   </p:cSld>

</xml_diff>